<commit_message>
L02: republish with the BPE and quadratic-attention slides
Two slides added since the first publish, both showing something the
lecture previously only asserted: byte-pair encoding walked through on
getOrderById, and the numbers behind quadratic attention. 29 slides to 31.

https://claude.ai/code/session_01Nac3M9CHSMSmoRnkHhPjB1
</commit_message>
<xml_diff>
--- a/lectures/L02/slides.pptx
+++ b/lectures/L02/slides.pptx
@@ -47,9 +47,11 @@
     <p:sldId id="295" r:id="rId41"/>
     <p:sldId id="296" r:id="rId42"/>
     <p:sldId id="297" r:id="rId43"/>
+    <p:sldId id="298" r:id="rId44"/>
+    <p:sldId id="299" r:id="rId45"/>
   </p:sldIdLst>
   <p:notesMasterIdLst>
-    <p:notesMasterId r:id="rId44"/>
+    <p:notesMasterId r:id="rId46"/>
   </p:notesMasterIdLst>
   <p:sldSz cx="9334500" cy="5248275"/>
   <p:notesSz cx="5248275" cy="9334500"/>
@@ -632,7 +634,7 @@
           <a:p>
             <a:r>
               <a:rPr lang="en-US" dirty="0"/>
-              <a:t>Rose accent on the surprising one — quality degradation.</a:t>
+              <a:t/>
             </a:r>
             <a:endParaRPr lang="en-US" dirty="0"/>
           </a:p>
@@ -720,7 +722,7 @@
           <a:p>
             <a:r>
               <a:rPr lang="en-US" dirty="0"/>
-              <a:t/>
+              <a:t>Rose accent on the surprising one — quality degradation.</a:t>
             </a:r>
             <a:endParaRPr lang="en-US" dirty="0"/>
           </a:p>
@@ -808,7 +810,8 @@
           <a:p>
             <a:r>
               <a:rPr lang="en-US" dirty="0"/>
-              <a:t/>
+              <a:t>The number to land: 32× the text is not 32× the cost, it is 1000×.
+This is why "just paste the repo in" fails on a laptop.</a:t>
             </a:r>
             <a:endParaRPr lang="en-US" dirty="0"/>
           </a:p>
@@ -851,6 +854,182 @@
 </file>
 
 <file path=ppt/notesSlides/notesSlide13.xml><?xml version="1.0" encoding="utf-8"?>
+<p:notes xmlns:a="http://schemas.openxmlformats.org/drawingml/2006/main" xmlns:r="http://schemas.openxmlformats.org/officeDocument/2006/relationships" xmlns:p="http://schemas.openxmlformats.org/presentationml/2006/main">
+  <p:cSld>
+    <p:spTree>
+      <p:nvGrpSpPr>
+        <p:cNvPr id="1" name=""/>
+        <p:cNvGrpSpPr/>
+        <p:nvPr/>
+      </p:nvGrpSpPr>
+      <p:grpSpPr>
+        <a:xfrm>
+          <a:off x="0" y="0"/>
+          <a:ext cx="0" cy="0"/>
+          <a:chOff x="0" y="0"/>
+          <a:chExt cx="0" cy="0"/>
+        </a:xfrm>
+      </p:grpSpPr>
+      <p:sp>
+        <p:nvSpPr>
+          <p:cNvPr id="2" name="Slide Image Placeholder 1"/>
+          <p:cNvSpPr>
+            <a:spLocks noGrp="1" noRot="1" noChangeAspect="1"/>
+          </p:cNvSpPr>
+          <p:nvPr>
+            <p:ph type="sldImg"/>
+          </p:nvPr>
+        </p:nvSpPr>
+        <p:spPr/>
+      </p:sp>
+      <p:sp>
+        <p:nvSpPr>
+          <p:cNvPr id="3" name="Notes Placeholder 2"/>
+          <p:cNvSpPr>
+            <a:spLocks noGrp="1"/>
+          </p:cNvSpPr>
+          <p:nvPr>
+            <p:ph type="body" idx="1"/>
+          </p:nvPr>
+        </p:nvSpPr>
+        <p:spPr/>
+        <p:txBody>
+          <a:bodyPr/>
+          <a:lstStyle/>
+          <a:p>
+            <a:r>
+              <a:rPr lang="en-US" dirty="0"/>
+              <a:t/>
+            </a:r>
+            <a:endParaRPr lang="en-US" dirty="0"/>
+          </a:p>
+        </p:txBody>
+      </p:sp>
+      <p:sp>
+        <p:nvSpPr>
+          <p:cNvPr id="4" name="Slide Number Placeholder 3"/>
+          <p:cNvSpPr>
+            <a:spLocks noGrp="1"/>
+          </p:cNvSpPr>
+          <p:nvPr>
+            <p:ph type="sldNum" sz="quarter" idx="10"/>
+          </p:nvPr>
+        </p:nvSpPr>
+        <p:spPr/>
+        <p:txBody>
+          <a:bodyPr/>
+          <a:lstStyle/>
+          <a:p>
+            <a:fld id="{F7021451-1387-4CA6-816F-3879F97B5CBC}" type="slidenum">
+              <a:rPr lang="en-US"/>
+              <a:t>13</a:t>
+            </a:fld>
+            <a:endParaRPr lang="en-US"/>
+          </a:p>
+        </p:txBody>
+      </p:sp>
+    </p:spTree>
+    <p:extLst>
+      <p:ext uri="{BB962C8B-B14F-4D97-AF65-F5344CB8AC3E}">
+        <p14:creationId xmlns:p14="http://schemas.microsoft.com/office/powerpoint/2010/main" val="1024086991"/>
+      </p:ext>
+    </p:extLst>
+  </p:cSld>
+  <p:clrMapOvr>
+    <a:masterClrMapping/>
+  </p:clrMapOvr>
+</p:notes>
+</file>
+
+<file path=ppt/notesSlides/notesSlide14.xml><?xml version="1.0" encoding="utf-8"?>
+<p:notes xmlns:a="http://schemas.openxmlformats.org/drawingml/2006/main" xmlns:r="http://schemas.openxmlformats.org/officeDocument/2006/relationships" xmlns:p="http://schemas.openxmlformats.org/presentationml/2006/main">
+  <p:cSld>
+    <p:spTree>
+      <p:nvGrpSpPr>
+        <p:cNvPr id="1" name=""/>
+        <p:cNvGrpSpPr/>
+        <p:nvPr/>
+      </p:nvGrpSpPr>
+      <p:grpSpPr>
+        <a:xfrm>
+          <a:off x="0" y="0"/>
+          <a:ext cx="0" cy="0"/>
+          <a:chOff x="0" y="0"/>
+          <a:chExt cx="0" cy="0"/>
+        </a:xfrm>
+      </p:grpSpPr>
+      <p:sp>
+        <p:nvSpPr>
+          <p:cNvPr id="2" name="Slide Image Placeholder 1"/>
+          <p:cNvSpPr>
+            <a:spLocks noGrp="1" noRot="1" noChangeAspect="1"/>
+          </p:cNvSpPr>
+          <p:nvPr>
+            <p:ph type="sldImg"/>
+          </p:nvPr>
+        </p:nvSpPr>
+        <p:spPr/>
+      </p:sp>
+      <p:sp>
+        <p:nvSpPr>
+          <p:cNvPr id="3" name="Notes Placeholder 2"/>
+          <p:cNvSpPr>
+            <a:spLocks noGrp="1"/>
+          </p:cNvSpPr>
+          <p:nvPr>
+            <p:ph type="body" idx="1"/>
+          </p:nvPr>
+        </p:nvSpPr>
+        <p:spPr/>
+        <p:txBody>
+          <a:bodyPr/>
+          <a:lstStyle/>
+          <a:p>
+            <a:r>
+              <a:rPr lang="en-US" dirty="0"/>
+              <a:t/>
+            </a:r>
+            <a:endParaRPr lang="en-US" dirty="0"/>
+          </a:p>
+        </p:txBody>
+      </p:sp>
+      <p:sp>
+        <p:nvSpPr>
+          <p:cNvPr id="4" name="Slide Number Placeholder 3"/>
+          <p:cNvSpPr>
+            <a:spLocks noGrp="1"/>
+          </p:cNvSpPr>
+          <p:nvPr>
+            <p:ph type="sldNum" sz="quarter" idx="10"/>
+          </p:nvPr>
+        </p:nvSpPr>
+        <p:spPr/>
+        <p:txBody>
+          <a:bodyPr/>
+          <a:lstStyle/>
+          <a:p>
+            <a:fld id="{F7021451-1387-4CA6-816F-3879F97B5CBC}" type="slidenum">
+              <a:rPr lang="en-US"/>
+              <a:t>14</a:t>
+            </a:fld>
+            <a:endParaRPr lang="en-US"/>
+          </a:p>
+        </p:txBody>
+      </p:sp>
+    </p:spTree>
+    <p:extLst>
+      <p:ext uri="{BB962C8B-B14F-4D97-AF65-F5344CB8AC3E}">
+        <p14:creationId xmlns:p14="http://schemas.microsoft.com/office/powerpoint/2010/main" val="1024086991"/>
+      </p:ext>
+    </p:extLst>
+  </p:cSld>
+  <p:clrMapOvr>
+    <a:masterClrMapping/>
+  </p:clrMapOvr>
+</p:notes>
+</file>
+
+<file path=ppt/notesSlides/notesSlide15.xml><?xml version="1.0" encoding="utf-8"?>
 <p:notes xmlns:a="http://schemas.openxmlformats.org/drawingml/2006/main" xmlns:r="http://schemas.openxmlformats.org/officeDocument/2006/relationships" xmlns:p="http://schemas.openxmlformats.org/presentationml/2006/main">
   <p:cSld>
     <p:spTree>
@@ -924,7 +1103,7 @@
           <a:p>
             <a:fld id="{F7021451-1387-4CA6-816F-3879F97B5CBC}" type="slidenum">
               <a:rPr lang="en-US"/>
-              <a:t>13</a:t>
+              <a:t>15</a:t>
             </a:fld>
             <a:endParaRPr lang="en-US"/>
           </a:p>
@@ -943,7 +1122,7 @@
 </p:notes>
 </file>
 
-<file path=ppt/notesSlides/notesSlide14.xml><?xml version="1.0" encoding="utf-8"?>
+<file path=ppt/notesSlides/notesSlide16.xml><?xml version="1.0" encoding="utf-8"?>
 <p:notes xmlns:a="http://schemas.openxmlformats.org/drawingml/2006/main" xmlns:r="http://schemas.openxmlformats.org/officeDocument/2006/relationships" xmlns:p="http://schemas.openxmlformats.org/presentationml/2006/main">
   <p:cSld>
     <p:spTree>
@@ -1012,7 +1191,7 @@
           <a:p>
             <a:fld id="{F7021451-1387-4CA6-816F-3879F97B5CBC}" type="slidenum">
               <a:rPr lang="en-US"/>
-              <a:t>14</a:t>
+              <a:t>16</a:t>
             </a:fld>
             <a:endParaRPr lang="en-US"/>
           </a:p>
@@ -1031,7 +1210,7 @@
 </p:notes>
 </file>
 
-<file path=ppt/notesSlides/notesSlide15.xml><?xml version="1.0" encoding="utf-8"?>
+<file path=ppt/notesSlides/notesSlide17.xml><?xml version="1.0" encoding="utf-8"?>
 <p:notes xmlns:a="http://schemas.openxmlformats.org/drawingml/2006/main" xmlns:r="http://schemas.openxmlformats.org/officeDocument/2006/relationships" xmlns:p="http://schemas.openxmlformats.org/presentationml/2006/main">
   <p:cSld>
     <p:spTree>
@@ -1100,7 +1279,7 @@
           <a:p>
             <a:fld id="{F7021451-1387-4CA6-816F-3879F97B5CBC}" type="slidenum">
               <a:rPr lang="en-US"/>
-              <a:t>15</a:t>
+              <a:t>17</a:t>
             </a:fld>
             <a:endParaRPr lang="en-US"/>
           </a:p>
@@ -1119,7 +1298,7 @@
 </p:notes>
 </file>
 
-<file path=ppt/notesSlides/notesSlide16.xml><?xml version="1.0" encoding="utf-8"?>
+<file path=ppt/notesSlides/notesSlide18.xml><?xml version="1.0" encoding="utf-8"?>
 <p:notes xmlns:a="http://schemas.openxmlformats.org/drawingml/2006/main" xmlns:r="http://schemas.openxmlformats.org/officeDocument/2006/relationships" xmlns:p="http://schemas.openxmlformats.org/presentationml/2006/main">
   <p:cSld>
     <p:spTree>
@@ -1188,7 +1367,7 @@
           <a:p>
             <a:fld id="{F7021451-1387-4CA6-816F-3879F97B5CBC}" type="slidenum">
               <a:rPr lang="en-US"/>
-              <a:t>16</a:t>
+              <a:t>18</a:t>
             </a:fld>
             <a:endParaRPr lang="en-US"/>
           </a:p>
@@ -1207,7 +1386,7 @@
 </p:notes>
 </file>
 
-<file path=ppt/notesSlides/notesSlide17.xml><?xml version="1.0" encoding="utf-8"?>
+<file path=ppt/notesSlides/notesSlide19.xml><?xml version="1.0" encoding="utf-8"?>
 <p:notes xmlns:a="http://schemas.openxmlformats.org/drawingml/2006/main" xmlns:r="http://schemas.openxmlformats.org/officeDocument/2006/relationships" xmlns:p="http://schemas.openxmlformats.org/presentationml/2006/main">
   <p:cSld>
     <p:spTree>
@@ -1276,7 +1455,7 @@
           <a:p>
             <a:fld id="{F7021451-1387-4CA6-816F-3879F97B5CBC}" type="slidenum">
               <a:rPr lang="en-US"/>
-              <a:t>17</a:t>
+              <a:t>19</a:t>
             </a:fld>
             <a:endParaRPr lang="en-US"/>
           </a:p>
@@ -1295,7 +1474,95 @@
 </p:notes>
 </file>
 
-<file path=ppt/notesSlides/notesSlide18.xml><?xml version="1.0" encoding="utf-8"?>
+<file path=ppt/notesSlides/notesSlide2.xml><?xml version="1.0" encoding="utf-8"?>
+<p:notes xmlns:a="http://schemas.openxmlformats.org/drawingml/2006/main" xmlns:r="http://schemas.openxmlformats.org/officeDocument/2006/relationships" xmlns:p="http://schemas.openxmlformats.org/presentationml/2006/main">
+  <p:cSld>
+    <p:spTree>
+      <p:nvGrpSpPr>
+        <p:cNvPr id="1" name=""/>
+        <p:cNvGrpSpPr/>
+        <p:nvPr/>
+      </p:nvGrpSpPr>
+      <p:grpSpPr>
+        <a:xfrm>
+          <a:off x="0" y="0"/>
+          <a:ext cx="0" cy="0"/>
+          <a:chOff x="0" y="0"/>
+          <a:chExt cx="0" cy="0"/>
+        </a:xfrm>
+      </p:grpSpPr>
+      <p:sp>
+        <p:nvSpPr>
+          <p:cNvPr id="2" name="Slide Image Placeholder 1"/>
+          <p:cNvSpPr>
+            <a:spLocks noGrp="1" noRot="1" noChangeAspect="1"/>
+          </p:cNvSpPr>
+          <p:nvPr>
+            <p:ph type="sldImg"/>
+          </p:nvPr>
+        </p:nvSpPr>
+        <p:spPr/>
+      </p:sp>
+      <p:sp>
+        <p:nvSpPr>
+          <p:cNvPr id="3" name="Notes Placeholder 2"/>
+          <p:cNvSpPr>
+            <a:spLocks noGrp="1"/>
+          </p:cNvSpPr>
+          <p:nvPr>
+            <p:ph type="body" idx="1"/>
+          </p:nvPr>
+        </p:nvSpPr>
+        <p:spPr/>
+        <p:txBody>
+          <a:bodyPr/>
+          <a:lstStyle/>
+          <a:p>
+            <a:r>
+              <a:rPr lang="en-US" dirty="0"/>
+              <a:t>The opener: why bother with theory. When it doesn't work, mental models win.</a:t>
+            </a:r>
+            <a:endParaRPr lang="en-US" dirty="0"/>
+          </a:p>
+        </p:txBody>
+      </p:sp>
+      <p:sp>
+        <p:nvSpPr>
+          <p:cNvPr id="4" name="Slide Number Placeholder 3"/>
+          <p:cNvSpPr>
+            <a:spLocks noGrp="1"/>
+          </p:cNvSpPr>
+          <p:nvPr>
+            <p:ph type="sldNum" sz="quarter" idx="10"/>
+          </p:nvPr>
+        </p:nvSpPr>
+        <p:spPr/>
+        <p:txBody>
+          <a:bodyPr/>
+          <a:lstStyle/>
+          <a:p>
+            <a:fld id="{F7021451-1387-4CA6-816F-3879F97B5CBC}" type="slidenum">
+              <a:rPr lang="en-US"/>
+              <a:t>2</a:t>
+            </a:fld>
+            <a:endParaRPr lang="en-US"/>
+          </a:p>
+        </p:txBody>
+      </p:sp>
+    </p:spTree>
+    <p:extLst>
+      <p:ext uri="{BB962C8B-B14F-4D97-AF65-F5344CB8AC3E}">
+        <p14:creationId xmlns:p14="http://schemas.microsoft.com/office/powerpoint/2010/main" val="1024086991"/>
+      </p:ext>
+    </p:extLst>
+  </p:cSld>
+  <p:clrMapOvr>
+    <a:masterClrMapping/>
+  </p:clrMapOvr>
+</p:notes>
+</file>
+
+<file path=ppt/notesSlides/notesSlide20.xml><?xml version="1.0" encoding="utf-8"?>
 <p:notes xmlns:a="http://schemas.openxmlformats.org/drawingml/2006/main" xmlns:r="http://schemas.openxmlformats.org/officeDocument/2006/relationships" xmlns:p="http://schemas.openxmlformats.org/presentationml/2006/main">
   <p:cSld>
     <p:spTree>
@@ -1364,7 +1631,7 @@
           <a:p>
             <a:fld id="{F7021451-1387-4CA6-816F-3879F97B5CBC}" type="slidenum">
               <a:rPr lang="en-US"/>
-              <a:t>18</a:t>
+              <a:t>20</a:t>
             </a:fld>
             <a:endParaRPr lang="en-US"/>
           </a:p>
@@ -1383,7 +1650,7 @@
 </p:notes>
 </file>
 
-<file path=ppt/notesSlides/notesSlide19.xml><?xml version="1.0" encoding="utf-8"?>
+<file path=ppt/notesSlides/notesSlide21.xml><?xml version="1.0" encoding="utf-8"?>
 <p:notes xmlns:a="http://schemas.openxmlformats.org/drawingml/2006/main" xmlns:r="http://schemas.openxmlformats.org/officeDocument/2006/relationships" xmlns:p="http://schemas.openxmlformats.org/presentationml/2006/main">
   <p:cSld>
     <p:spTree>
@@ -1452,7 +1719,7 @@
           <a:p>
             <a:fld id="{F7021451-1387-4CA6-816F-3879F97B5CBC}" type="slidenum">
               <a:rPr lang="en-US"/>
-              <a:t>19</a:t>
+              <a:t>21</a:t>
             </a:fld>
             <a:endParaRPr lang="en-US"/>
           </a:p>
@@ -1471,7 +1738,7 @@
 </p:notes>
 </file>
 
-<file path=ppt/notesSlides/notesSlide2.xml><?xml version="1.0" encoding="utf-8"?>
+<file path=ppt/notesSlides/notesSlide22.xml><?xml version="1.0" encoding="utf-8"?>
 <p:notes xmlns:a="http://schemas.openxmlformats.org/drawingml/2006/main" xmlns:r="http://schemas.openxmlformats.org/officeDocument/2006/relationships" xmlns:p="http://schemas.openxmlformats.org/presentationml/2006/main">
   <p:cSld>
     <p:spTree>
@@ -1517,7 +1784,7 @@
           <a:p>
             <a:r>
               <a:rPr lang="en-US" dirty="0"/>
-              <a:t>The opener: why bother with theory. When it doesn't work, mental models win.</a:t>
+              <a:t>"Hallucination" sounds like a mistake. It's not a mistake — it's the design.</a:t>
             </a:r>
             <a:endParaRPr lang="en-US" dirty="0"/>
           </a:p>
@@ -1540,7 +1807,7 @@
           <a:p>
             <a:fld id="{F7021451-1387-4CA6-816F-3879F97B5CBC}" type="slidenum">
               <a:rPr lang="en-US"/>
-              <a:t>2</a:t>
+              <a:t>22</a:t>
             </a:fld>
             <a:endParaRPr lang="en-US"/>
           </a:p>
@@ -1559,7 +1826,7 @@
 </p:notes>
 </file>
 
-<file path=ppt/notesSlides/notesSlide20.xml><?xml version="1.0" encoding="utf-8"?>
+<file path=ppt/notesSlides/notesSlide23.xml><?xml version="1.0" encoding="utf-8"?>
 <p:notes xmlns:a="http://schemas.openxmlformats.org/drawingml/2006/main" xmlns:r="http://schemas.openxmlformats.org/officeDocument/2006/relationships" xmlns:p="http://schemas.openxmlformats.org/presentationml/2006/main">
   <p:cSld>
     <p:spTree>
@@ -1605,7 +1872,7 @@
           <a:p>
             <a:r>
               <a:rPr lang="en-US" dirty="0"/>
-              <a:t>"Hallucination" sounds like a mistake. It's not a mistake — it's the design.</a:t>
+              <a:t>Not "made up" — wrong real library for the wrong real project.</a:t>
             </a:r>
             <a:endParaRPr lang="en-US" dirty="0"/>
           </a:p>
@@ -1628,7 +1895,7 @@
           <a:p>
             <a:fld id="{F7021451-1387-4CA6-816F-3879F97B5CBC}" type="slidenum">
               <a:rPr lang="en-US"/>
-              <a:t>20</a:t>
+              <a:t>23</a:t>
             </a:fld>
             <a:endParaRPr lang="en-US"/>
           </a:p>
@@ -1647,7 +1914,7 @@
 </p:notes>
 </file>
 
-<file path=ppt/notesSlides/notesSlide21.xml><?xml version="1.0" encoding="utf-8"?>
+<file path=ppt/notesSlides/notesSlide24.xml><?xml version="1.0" encoding="utf-8"?>
 <p:notes xmlns:a="http://schemas.openxmlformats.org/drawingml/2006/main" xmlns:r="http://schemas.openxmlformats.org/officeDocument/2006/relationships" xmlns:p="http://schemas.openxmlformats.org/presentationml/2006/main">
   <p:cSld>
     <p:spTree>
@@ -1716,7 +1983,7 @@
           <a:p>
             <a:fld id="{F7021451-1387-4CA6-816F-3879F97B5CBC}" type="slidenum">
               <a:rPr lang="en-US"/>
-              <a:t>21</a:t>
+              <a:t>24</a:t>
             </a:fld>
             <a:endParaRPr lang="en-US"/>
           </a:p>
@@ -1735,7 +2002,7 @@
 </p:notes>
 </file>
 
-<file path=ppt/notesSlides/notesSlide22.xml><?xml version="1.0" encoding="utf-8"?>
+<file path=ppt/notesSlides/notesSlide25.xml><?xml version="1.0" encoding="utf-8"?>
 <p:notes xmlns:a="http://schemas.openxmlformats.org/drawingml/2006/main" xmlns:r="http://schemas.openxmlformats.org/officeDocument/2006/relationships" xmlns:p="http://schemas.openxmlformats.org/presentationml/2006/main">
   <p:cSld>
     <p:spTree>
@@ -1804,7 +2071,7 @@
           <a:p>
             <a:fld id="{F7021451-1387-4CA6-816F-3879F97B5CBC}" type="slidenum">
               <a:rPr lang="en-US"/>
-              <a:t>22</a:t>
+              <a:t>25</a:t>
             </a:fld>
             <a:endParaRPr lang="en-US"/>
           </a:p>
@@ -1823,7 +2090,7 @@
 </p:notes>
 </file>
 
-<file path=ppt/notesSlides/notesSlide23.xml><?xml version="1.0" encoding="utf-8"?>
+<file path=ppt/notesSlides/notesSlide26.xml><?xml version="1.0" encoding="utf-8"?>
 <p:notes xmlns:a="http://schemas.openxmlformats.org/drawingml/2006/main" xmlns:r="http://schemas.openxmlformats.org/officeDocument/2006/relationships" xmlns:p="http://schemas.openxmlformats.org/presentationml/2006/main">
   <p:cSld>
     <p:spTree>
@@ -1892,7 +2159,7 @@
           <a:p>
             <a:fld id="{F7021451-1387-4CA6-816F-3879F97B5CBC}" type="slidenum">
               <a:rPr lang="en-US"/>
-              <a:t>23</a:t>
+              <a:t>26</a:t>
             </a:fld>
             <a:endParaRPr lang="en-US"/>
           </a:p>
@@ -1911,7 +2178,7 @@
 </p:notes>
 </file>
 
-<file path=ppt/notesSlides/notesSlide24.xml><?xml version="1.0" encoding="utf-8"?>
+<file path=ppt/notesSlides/notesSlide27.xml><?xml version="1.0" encoding="utf-8"?>
 <p:notes xmlns:a="http://schemas.openxmlformats.org/drawingml/2006/main" xmlns:r="http://schemas.openxmlformats.org/officeDocument/2006/relationships" xmlns:p="http://schemas.openxmlformats.org/presentationml/2006/main">
   <p:cSld>
     <p:spTree>
@@ -1980,7 +2247,7 @@
           <a:p>
             <a:fld id="{F7021451-1387-4CA6-816F-3879F97B5CBC}" type="slidenum">
               <a:rPr lang="en-US"/>
-              <a:t>24</a:t>
+              <a:t>27</a:t>
             </a:fld>
             <a:endParaRPr lang="en-US"/>
           </a:p>
@@ -1999,7 +2266,7 @@
 </p:notes>
 </file>
 
-<file path=ppt/notesSlides/notesSlide25.xml><?xml version="1.0" encoding="utf-8"?>
+<file path=ppt/notesSlides/notesSlide28.xml><?xml version="1.0" encoding="utf-8"?>
 <p:notes xmlns:a="http://schemas.openxmlformats.org/drawingml/2006/main" xmlns:r="http://schemas.openxmlformats.org/officeDocument/2006/relationships" xmlns:p="http://schemas.openxmlformats.org/presentationml/2006/main">
   <p:cSld>
     <p:spTree>
@@ -2045,7 +2312,7 @@
           <a:p>
             <a:r>
               <a:rPr lang="en-US" dirty="0"/>
-              <a:t>Not "made up" — wrong real library for the wrong real project.</a:t>
+              <a:t/>
             </a:r>
             <a:endParaRPr lang="en-US" dirty="0"/>
           </a:p>
@@ -2068,7 +2335,7 @@
           <a:p>
             <a:fld id="{F7021451-1387-4CA6-816F-3879F97B5CBC}" type="slidenum">
               <a:rPr lang="en-US"/>
-              <a:t>25</a:t>
+              <a:t>28</a:t>
             </a:fld>
             <a:endParaRPr lang="en-US"/>
           </a:p>
@@ -2087,7 +2354,95 @@
 </p:notes>
 </file>
 
-<file path=ppt/notesSlides/notesSlide26.xml><?xml version="1.0" encoding="utf-8"?>
+<file path=ppt/notesSlides/notesSlide29.xml><?xml version="1.0" encoding="utf-8"?>
+<p:notes xmlns:a="http://schemas.openxmlformats.org/drawingml/2006/main" xmlns:r="http://schemas.openxmlformats.org/officeDocument/2006/relationships" xmlns:p="http://schemas.openxmlformats.org/presentationml/2006/main">
+  <p:cSld>
+    <p:spTree>
+      <p:nvGrpSpPr>
+        <p:cNvPr id="1" name=""/>
+        <p:cNvGrpSpPr/>
+        <p:nvPr/>
+      </p:nvGrpSpPr>
+      <p:grpSpPr>
+        <a:xfrm>
+          <a:off x="0" y="0"/>
+          <a:ext cx="0" cy="0"/>
+          <a:chOff x="0" y="0"/>
+          <a:chExt cx="0" cy="0"/>
+        </a:xfrm>
+      </p:grpSpPr>
+      <p:sp>
+        <p:nvSpPr>
+          <p:cNvPr id="2" name="Slide Image Placeholder 1"/>
+          <p:cNvSpPr>
+            <a:spLocks noGrp="1" noRot="1" noChangeAspect="1"/>
+          </p:cNvSpPr>
+          <p:nvPr>
+            <p:ph type="sldImg"/>
+          </p:nvPr>
+        </p:nvSpPr>
+        <p:spPr/>
+      </p:sp>
+      <p:sp>
+        <p:nvSpPr>
+          <p:cNvPr id="3" name="Notes Placeholder 2"/>
+          <p:cNvSpPr>
+            <a:spLocks noGrp="1"/>
+          </p:cNvSpPr>
+          <p:nvPr>
+            <p:ph type="body" idx="1"/>
+          </p:nvPr>
+        </p:nvSpPr>
+        <p:spPr/>
+        <p:txBody>
+          <a:bodyPr/>
+          <a:lstStyle/>
+          <a:p>
+            <a:r>
+              <a:rPr lang="en-US" dirty="0"/>
+              <a:t>The deepest reason to manage context: accuracy. Not cost. Not speed.</a:t>
+            </a:r>
+            <a:endParaRPr lang="en-US" dirty="0"/>
+          </a:p>
+        </p:txBody>
+      </p:sp>
+      <p:sp>
+        <p:nvSpPr>
+          <p:cNvPr id="4" name="Slide Number Placeholder 3"/>
+          <p:cNvSpPr>
+            <a:spLocks noGrp="1"/>
+          </p:cNvSpPr>
+          <p:nvPr>
+            <p:ph type="sldNum" sz="quarter" idx="10"/>
+          </p:nvPr>
+        </p:nvSpPr>
+        <p:spPr/>
+        <p:txBody>
+          <a:bodyPr/>
+          <a:lstStyle/>
+          <a:p>
+            <a:fld id="{F7021451-1387-4CA6-816F-3879F97B5CBC}" type="slidenum">
+              <a:rPr lang="en-US"/>
+              <a:t>29</a:t>
+            </a:fld>
+            <a:endParaRPr lang="en-US"/>
+          </a:p>
+        </p:txBody>
+      </p:sp>
+    </p:spTree>
+    <p:extLst>
+      <p:ext uri="{BB962C8B-B14F-4D97-AF65-F5344CB8AC3E}">
+        <p14:creationId xmlns:p14="http://schemas.microsoft.com/office/powerpoint/2010/main" val="1024086991"/>
+      </p:ext>
+    </p:extLst>
+  </p:cSld>
+  <p:clrMapOvr>
+    <a:masterClrMapping/>
+  </p:clrMapOvr>
+</p:notes>
+</file>
+
+<file path=ppt/notesSlides/notesSlide3.xml><?xml version="1.0" encoding="utf-8"?>
 <p:notes xmlns:a="http://schemas.openxmlformats.org/drawingml/2006/main" xmlns:r="http://schemas.openxmlformats.org/officeDocument/2006/relationships" xmlns:p="http://schemas.openxmlformats.org/presentationml/2006/main">
   <p:cSld>
     <p:spTree>
@@ -2156,7 +2511,7 @@
           <a:p>
             <a:fld id="{F7021451-1387-4CA6-816F-3879F97B5CBC}" type="slidenum">
               <a:rPr lang="en-US"/>
-              <a:t>26</a:t>
+              <a:t>3</a:t>
             </a:fld>
             <a:endParaRPr lang="en-US"/>
           </a:p>
@@ -2175,7 +2530,7 @@
 </p:notes>
 </file>
 
-<file path=ppt/notesSlides/notesSlide27.xml><?xml version="1.0" encoding="utf-8"?>
+<file path=ppt/notesSlides/notesSlide30.xml><?xml version="1.0" encoding="utf-8"?>
 <p:notes xmlns:a="http://schemas.openxmlformats.org/drawingml/2006/main" xmlns:r="http://schemas.openxmlformats.org/officeDocument/2006/relationships" xmlns:p="http://schemas.openxmlformats.org/presentationml/2006/main">
   <p:cSld>
     <p:spTree>
@@ -2221,7 +2576,7 @@
           <a:p>
             <a:r>
               <a:rPr lang="en-US" dirty="0"/>
-              <a:t>The deepest reason to manage context: accuracy. Not cost. Not speed.</a:t>
+              <a:t/>
             </a:r>
             <a:endParaRPr lang="en-US" dirty="0"/>
           </a:p>
@@ -2244,7 +2599,7 @@
           <a:p>
             <a:fld id="{F7021451-1387-4CA6-816F-3879F97B5CBC}" type="slidenum">
               <a:rPr lang="en-US"/>
-              <a:t>27</a:t>
+              <a:t>30</a:t>
             </a:fld>
             <a:endParaRPr lang="en-US"/>
           </a:p>
@@ -2263,7 +2618,7 @@
 </p:notes>
 </file>
 
-<file path=ppt/notesSlides/notesSlide28.xml><?xml version="1.0" encoding="utf-8"?>
+<file path=ppt/notesSlides/notesSlide31.xml><?xml version="1.0" encoding="utf-8"?>
 <p:notes xmlns:a="http://schemas.openxmlformats.org/drawingml/2006/main" xmlns:r="http://schemas.openxmlformats.org/officeDocument/2006/relationships" xmlns:p="http://schemas.openxmlformats.org/presentationml/2006/main">
   <p:cSld>
     <p:spTree>
@@ -2332,7 +2687,7 @@
           <a:p>
             <a:fld id="{F7021451-1387-4CA6-816F-3879F97B5CBC}" type="slidenum">
               <a:rPr lang="en-US"/>
-              <a:t>28</a:t>
+              <a:t>31</a:t>
             </a:fld>
             <a:endParaRPr lang="en-US"/>
           </a:p>
@@ -2351,7 +2706,7 @@
 </p:notes>
 </file>
 
-<file path=ppt/notesSlides/notesSlide29.xml><?xml version="1.0" encoding="utf-8"?>
+<file path=ppt/notesSlides/notesSlide32.xml><?xml version="1.0" encoding="utf-8"?>
 <p:notes xmlns:a="http://schemas.openxmlformats.org/drawingml/2006/main" xmlns:r="http://schemas.openxmlformats.org/officeDocument/2006/relationships" xmlns:p="http://schemas.openxmlformats.org/presentationml/2006/main">
   <p:cSld>
     <p:spTree>
@@ -2397,7 +2752,7 @@
           <a:p>
             <a:r>
               <a:rPr lang="en-US" dirty="0"/>
-              <a:t/>
+              <a:t>Two axes. Confusing them = bad model choices.</a:t>
             </a:r>
             <a:endParaRPr lang="en-US" dirty="0"/>
           </a:p>
@@ -2420,7 +2775,7 @@
           <a:p>
             <a:fld id="{F7021451-1387-4CA6-816F-3879F97B5CBC}" type="slidenum">
               <a:rPr lang="en-US"/>
-              <a:t>29</a:t>
+              <a:t>32</a:t>
             </a:fld>
             <a:endParaRPr lang="en-US"/>
           </a:p>
@@ -2439,183 +2794,7 @@
 </p:notes>
 </file>
 
-<file path=ppt/notesSlides/notesSlide3.xml><?xml version="1.0" encoding="utf-8"?>
-<p:notes xmlns:a="http://schemas.openxmlformats.org/drawingml/2006/main" xmlns:r="http://schemas.openxmlformats.org/officeDocument/2006/relationships" xmlns:p="http://schemas.openxmlformats.org/presentationml/2006/main">
-  <p:cSld>
-    <p:spTree>
-      <p:nvGrpSpPr>
-        <p:cNvPr id="1" name=""/>
-        <p:cNvGrpSpPr/>
-        <p:nvPr/>
-      </p:nvGrpSpPr>
-      <p:grpSpPr>
-        <a:xfrm>
-          <a:off x="0" y="0"/>
-          <a:ext cx="0" cy="0"/>
-          <a:chOff x="0" y="0"/>
-          <a:chExt cx="0" cy="0"/>
-        </a:xfrm>
-      </p:grpSpPr>
-      <p:sp>
-        <p:nvSpPr>
-          <p:cNvPr id="2" name="Slide Image Placeholder 1"/>
-          <p:cNvSpPr>
-            <a:spLocks noGrp="1" noRot="1" noChangeAspect="1"/>
-          </p:cNvSpPr>
-          <p:nvPr>
-            <p:ph type="sldImg"/>
-          </p:nvPr>
-        </p:nvSpPr>
-        <p:spPr/>
-      </p:sp>
-      <p:sp>
-        <p:nvSpPr>
-          <p:cNvPr id="3" name="Notes Placeholder 2"/>
-          <p:cNvSpPr>
-            <a:spLocks noGrp="1"/>
-          </p:cNvSpPr>
-          <p:nvPr>
-            <p:ph type="body" idx="1"/>
-          </p:nvPr>
-        </p:nvSpPr>
-        <p:spPr/>
-        <p:txBody>
-          <a:bodyPr/>
-          <a:lstStyle/>
-          <a:p>
-            <a:r>
-              <a:rPr lang="en-US" dirty="0"/>
-              <a:t/>
-            </a:r>
-            <a:endParaRPr lang="en-US" dirty="0"/>
-          </a:p>
-        </p:txBody>
-      </p:sp>
-      <p:sp>
-        <p:nvSpPr>
-          <p:cNvPr id="4" name="Slide Number Placeholder 3"/>
-          <p:cNvSpPr>
-            <a:spLocks noGrp="1"/>
-          </p:cNvSpPr>
-          <p:nvPr>
-            <p:ph type="sldNum" sz="quarter" idx="10"/>
-          </p:nvPr>
-        </p:nvSpPr>
-        <p:spPr/>
-        <p:txBody>
-          <a:bodyPr/>
-          <a:lstStyle/>
-          <a:p>
-            <a:fld id="{F7021451-1387-4CA6-816F-3879F97B5CBC}" type="slidenum">
-              <a:rPr lang="en-US"/>
-              <a:t>3</a:t>
-            </a:fld>
-            <a:endParaRPr lang="en-US"/>
-          </a:p>
-        </p:txBody>
-      </p:sp>
-    </p:spTree>
-    <p:extLst>
-      <p:ext uri="{BB962C8B-B14F-4D97-AF65-F5344CB8AC3E}">
-        <p14:creationId xmlns:p14="http://schemas.microsoft.com/office/powerpoint/2010/main" val="1024086991"/>
-      </p:ext>
-    </p:extLst>
-  </p:cSld>
-  <p:clrMapOvr>
-    <a:masterClrMapping/>
-  </p:clrMapOvr>
-</p:notes>
-</file>
-
-<file path=ppt/notesSlides/notesSlide30.xml><?xml version="1.0" encoding="utf-8"?>
-<p:notes xmlns:a="http://schemas.openxmlformats.org/drawingml/2006/main" xmlns:r="http://schemas.openxmlformats.org/officeDocument/2006/relationships" xmlns:p="http://schemas.openxmlformats.org/presentationml/2006/main">
-  <p:cSld>
-    <p:spTree>
-      <p:nvGrpSpPr>
-        <p:cNvPr id="1" name=""/>
-        <p:cNvGrpSpPr/>
-        <p:nvPr/>
-      </p:nvGrpSpPr>
-      <p:grpSpPr>
-        <a:xfrm>
-          <a:off x="0" y="0"/>
-          <a:ext cx="0" cy="0"/>
-          <a:chOff x="0" y="0"/>
-          <a:chExt cx="0" cy="0"/>
-        </a:xfrm>
-      </p:grpSpPr>
-      <p:sp>
-        <p:nvSpPr>
-          <p:cNvPr id="2" name="Slide Image Placeholder 1"/>
-          <p:cNvSpPr>
-            <a:spLocks noGrp="1" noRot="1" noChangeAspect="1"/>
-          </p:cNvSpPr>
-          <p:nvPr>
-            <p:ph type="sldImg"/>
-          </p:nvPr>
-        </p:nvSpPr>
-        <p:spPr/>
-      </p:sp>
-      <p:sp>
-        <p:nvSpPr>
-          <p:cNvPr id="3" name="Notes Placeholder 2"/>
-          <p:cNvSpPr>
-            <a:spLocks noGrp="1"/>
-          </p:cNvSpPr>
-          <p:nvPr>
-            <p:ph type="body" idx="1"/>
-          </p:nvPr>
-        </p:nvSpPr>
-        <p:spPr/>
-        <p:txBody>
-          <a:bodyPr/>
-          <a:lstStyle/>
-          <a:p>
-            <a:r>
-              <a:rPr lang="en-US" dirty="0"/>
-              <a:t>Two axes. Confusing them = bad model choices.</a:t>
-            </a:r>
-            <a:endParaRPr lang="en-US" dirty="0"/>
-          </a:p>
-        </p:txBody>
-      </p:sp>
-      <p:sp>
-        <p:nvSpPr>
-          <p:cNvPr id="4" name="Slide Number Placeholder 3"/>
-          <p:cNvSpPr>
-            <a:spLocks noGrp="1"/>
-          </p:cNvSpPr>
-          <p:nvPr>
-            <p:ph type="sldNum" sz="quarter" idx="10"/>
-          </p:nvPr>
-        </p:nvSpPr>
-        <p:spPr/>
-        <p:txBody>
-          <a:bodyPr/>
-          <a:lstStyle/>
-          <a:p>
-            <a:fld id="{F7021451-1387-4CA6-816F-3879F97B5CBC}" type="slidenum">
-              <a:rPr lang="en-US"/>
-              <a:t>30</a:t>
-            </a:fld>
-            <a:endParaRPr lang="en-US"/>
-          </a:p>
-        </p:txBody>
-      </p:sp>
-    </p:spTree>
-    <p:extLst>
-      <p:ext uri="{BB962C8B-B14F-4D97-AF65-F5344CB8AC3E}">
-        <p14:creationId xmlns:p14="http://schemas.microsoft.com/office/powerpoint/2010/main" val="1024086991"/>
-      </p:ext>
-    </p:extLst>
-  </p:cSld>
-  <p:clrMapOvr>
-    <a:masterClrMapping/>
-  </p:clrMapOvr>
-</p:notes>
-</file>
-
-<file path=ppt/notesSlides/notesSlide31.xml><?xml version="1.0" encoding="utf-8"?>
+<file path=ppt/notesSlides/notesSlide33.xml><?xml version="1.0" encoding="utf-8"?>
 <p:notes xmlns:a="http://schemas.openxmlformats.org/drawingml/2006/main" xmlns:r="http://schemas.openxmlformats.org/officeDocument/2006/relationships" xmlns:p="http://schemas.openxmlformats.org/presentationml/2006/main">
   <p:cSld>
     <p:spTree>
@@ -2685,7 +2864,7 @@
           <a:p>
             <a:fld id="{F7021451-1387-4CA6-816F-3879F97B5CBC}" type="slidenum">
               <a:rPr lang="en-US"/>
-              <a:t>31</a:t>
+              <a:t>33</a:t>
             </a:fld>
             <a:endParaRPr lang="en-US"/>
           </a:p>
@@ -2704,7 +2883,7 @@
 </p:notes>
 </file>
 
-<file path=ppt/notesSlides/notesSlide32.xml><?xml version="1.0" encoding="utf-8"?>
+<file path=ppt/notesSlides/notesSlide34.xml><?xml version="1.0" encoding="utf-8"?>
 <p:notes xmlns:a="http://schemas.openxmlformats.org/drawingml/2006/main" xmlns:r="http://schemas.openxmlformats.org/officeDocument/2006/relationships" xmlns:p="http://schemas.openxmlformats.org/presentationml/2006/main">
   <p:cSld>
     <p:spTree>
@@ -2773,7 +2952,7 @@
           <a:p>
             <a:fld id="{F7021451-1387-4CA6-816F-3879F97B5CBC}" type="slidenum">
               <a:rPr lang="en-US"/>
-              <a:t>32</a:t>
+              <a:t>34</a:t>
             </a:fld>
             <a:endParaRPr lang="en-US"/>
           </a:p>
@@ -2792,7 +2971,7 @@
 </p:notes>
 </file>
 
-<file path=ppt/notesSlides/notesSlide33.xml><?xml version="1.0" encoding="utf-8"?>
+<file path=ppt/notesSlides/notesSlide35.xml><?xml version="1.0" encoding="utf-8"?>
 <p:notes xmlns:a="http://schemas.openxmlformats.org/drawingml/2006/main" xmlns:r="http://schemas.openxmlformats.org/officeDocument/2006/relationships" xmlns:p="http://schemas.openxmlformats.org/presentationml/2006/main">
   <p:cSld>
     <p:spTree>
@@ -2861,7 +3040,7 @@
           <a:p>
             <a:fld id="{F7021451-1387-4CA6-816F-3879F97B5CBC}" type="slidenum">
               <a:rPr lang="en-US"/>
-              <a:t>33</a:t>
+              <a:t>35</a:t>
             </a:fld>
             <a:endParaRPr lang="en-US"/>
           </a:p>
@@ -2880,7 +3059,7 @@
 </p:notes>
 </file>
 
-<file path=ppt/notesSlides/notesSlide34.xml><?xml version="1.0" encoding="utf-8"?>
+<file path=ppt/notesSlides/notesSlide36.xml><?xml version="1.0" encoding="utf-8"?>
 <p:notes xmlns:a="http://schemas.openxmlformats.org/drawingml/2006/main" xmlns:r="http://schemas.openxmlformats.org/officeDocument/2006/relationships" xmlns:p="http://schemas.openxmlformats.org/presentationml/2006/main">
   <p:cSld>
     <p:spTree>
@@ -2949,7 +3128,7 @@
           <a:p>
             <a:fld id="{F7021451-1387-4CA6-816F-3879F97B5CBC}" type="slidenum">
               <a:rPr lang="en-US"/>
-              <a:t>34</a:t>
+              <a:t>36</a:t>
             </a:fld>
             <a:endParaRPr lang="en-US"/>
           </a:p>
@@ -2968,7 +3147,7 @@
 </p:notes>
 </file>
 
-<file path=ppt/notesSlides/notesSlide35.xml><?xml version="1.0" encoding="utf-8"?>
+<file path=ppt/notesSlides/notesSlide37.xml><?xml version="1.0" encoding="utf-8"?>
 <p:notes xmlns:a="http://schemas.openxmlformats.org/drawingml/2006/main" xmlns:r="http://schemas.openxmlformats.org/officeDocument/2006/relationships" xmlns:p="http://schemas.openxmlformats.org/presentationml/2006/main">
   <p:cSld>
     <p:spTree>
@@ -3037,7 +3216,7 @@
           <a:p>
             <a:fld id="{F7021451-1387-4CA6-816F-3879F97B5CBC}" type="slidenum">
               <a:rPr lang="en-US"/>
-              <a:t>35</a:t>
+              <a:t>37</a:t>
             </a:fld>
             <a:endParaRPr lang="en-US"/>
           </a:p>
@@ -3056,7 +3235,7 @@
 </p:notes>
 </file>
 
-<file path=ppt/notesSlides/notesSlide36.xml><?xml version="1.0" encoding="utf-8"?>
+<file path=ppt/notesSlides/notesSlide38.xml><?xml version="1.0" encoding="utf-8"?>
 <p:notes xmlns:a="http://schemas.openxmlformats.org/drawingml/2006/main" xmlns:r="http://schemas.openxmlformats.org/officeDocument/2006/relationships" xmlns:p="http://schemas.openxmlformats.org/presentationml/2006/main">
   <p:cSld>
     <p:spTree>
@@ -3125,7 +3304,7 @@
           <a:p>
             <a:fld id="{F7021451-1387-4CA6-816F-3879F97B5CBC}" type="slidenum">
               <a:rPr lang="en-US"/>
-              <a:t>36</a:t>
+              <a:t>38</a:t>
             </a:fld>
             <a:endParaRPr lang="en-US"/>
           </a:p>
@@ -3144,7 +3323,7 @@
 </p:notes>
 </file>
 
-<file path=ppt/notesSlides/notesSlide37.xml><?xml version="1.0" encoding="utf-8"?>
+<file path=ppt/notesSlides/notesSlide39.xml><?xml version="1.0" encoding="utf-8"?>
 <p:notes xmlns:a="http://schemas.openxmlformats.org/drawingml/2006/main" xmlns:r="http://schemas.openxmlformats.org/officeDocument/2006/relationships" xmlns:p="http://schemas.openxmlformats.org/presentationml/2006/main">
   <p:cSld>
     <p:spTree>
@@ -3213,7 +3392,7 @@
           <a:p>
             <a:fld id="{F7021451-1387-4CA6-816F-3879F97B5CBC}" type="slidenum">
               <a:rPr lang="en-US"/>
-              <a:t>37</a:t>
+              <a:t>39</a:t>
             </a:fld>
             <a:endParaRPr lang="en-US"/>
           </a:p>
@@ -3232,7 +3411,7 @@
 </p:notes>
 </file>
 
-<file path=ppt/notesSlides/notesSlide38.xml><?xml version="1.0" encoding="utf-8"?>
+<file path=ppt/notesSlides/notesSlide4.xml><?xml version="1.0" encoding="utf-8"?>
 <p:notes xmlns:a="http://schemas.openxmlformats.org/drawingml/2006/main" xmlns:r="http://schemas.openxmlformats.org/officeDocument/2006/relationships" xmlns:p="http://schemas.openxmlformats.org/presentationml/2006/main">
   <p:cSld>
     <p:spTree>
@@ -3301,7 +3480,7 @@
           <a:p>
             <a:fld id="{F7021451-1387-4CA6-816F-3879F97B5CBC}" type="slidenum">
               <a:rPr lang="en-US"/>
-              <a:t>38</a:t>
+              <a:t>4</a:t>
             </a:fld>
             <a:endParaRPr lang="en-US"/>
           </a:p>
@@ -3320,7 +3499,95 @@
 </p:notes>
 </file>
 
-<file path=ppt/notesSlides/notesSlide39.xml><?xml version="1.0" encoding="utf-8"?>
+<file path=ppt/notesSlides/notesSlide40.xml><?xml version="1.0" encoding="utf-8"?>
+<p:notes xmlns:a="http://schemas.openxmlformats.org/drawingml/2006/main" xmlns:r="http://schemas.openxmlformats.org/officeDocument/2006/relationships" xmlns:p="http://schemas.openxmlformats.org/presentationml/2006/main">
+  <p:cSld>
+    <p:spTree>
+      <p:nvGrpSpPr>
+        <p:cNvPr id="1" name=""/>
+        <p:cNvGrpSpPr/>
+        <p:nvPr/>
+      </p:nvGrpSpPr>
+      <p:grpSpPr>
+        <a:xfrm>
+          <a:off x="0" y="0"/>
+          <a:ext cx="0" cy="0"/>
+          <a:chOff x="0" y="0"/>
+          <a:chExt cx="0" cy="0"/>
+        </a:xfrm>
+      </p:grpSpPr>
+      <p:sp>
+        <p:nvSpPr>
+          <p:cNvPr id="2" name="Slide Image Placeholder 1"/>
+          <p:cNvSpPr>
+            <a:spLocks noGrp="1" noRot="1" noChangeAspect="1"/>
+          </p:cNvSpPr>
+          <p:nvPr>
+            <p:ph type="sldImg"/>
+          </p:nvPr>
+        </p:nvSpPr>
+        <p:spPr/>
+      </p:sp>
+      <p:sp>
+        <p:nvSpPr>
+          <p:cNvPr id="3" name="Notes Placeholder 2"/>
+          <p:cNvSpPr>
+            <a:spLocks noGrp="1"/>
+          </p:cNvSpPr>
+          <p:nvPr>
+            <p:ph type="body" idx="1"/>
+          </p:nvPr>
+        </p:nvSpPr>
+        <p:spPr/>
+        <p:txBody>
+          <a:bodyPr/>
+          <a:lstStyle/>
+          <a:p>
+            <a:r>
+              <a:rPr lang="en-US" dirty="0"/>
+              <a:t/>
+            </a:r>
+            <a:endParaRPr lang="en-US" dirty="0"/>
+          </a:p>
+        </p:txBody>
+      </p:sp>
+      <p:sp>
+        <p:nvSpPr>
+          <p:cNvPr id="4" name="Slide Number Placeholder 3"/>
+          <p:cNvSpPr>
+            <a:spLocks noGrp="1"/>
+          </p:cNvSpPr>
+          <p:nvPr>
+            <p:ph type="sldNum" sz="quarter" idx="10"/>
+          </p:nvPr>
+        </p:nvSpPr>
+        <p:spPr/>
+        <p:txBody>
+          <a:bodyPr/>
+          <a:lstStyle/>
+          <a:p>
+            <a:fld id="{F7021451-1387-4CA6-816F-3879F97B5CBC}" type="slidenum">
+              <a:rPr lang="en-US"/>
+              <a:t>40</a:t>
+            </a:fld>
+            <a:endParaRPr lang="en-US"/>
+          </a:p>
+        </p:txBody>
+      </p:sp>
+    </p:spTree>
+    <p:extLst>
+      <p:ext uri="{BB962C8B-B14F-4D97-AF65-F5344CB8AC3E}">
+        <p14:creationId xmlns:p14="http://schemas.microsoft.com/office/powerpoint/2010/main" val="1024086991"/>
+      </p:ext>
+    </p:extLst>
+  </p:cSld>
+  <p:clrMapOvr>
+    <a:masterClrMapping/>
+  </p:clrMapOvr>
+</p:notes>
+</file>
+
+<file path=ppt/notesSlides/notesSlide41.xml><?xml version="1.0" encoding="utf-8"?>
 <p:notes xmlns:a="http://schemas.openxmlformats.org/drawingml/2006/main" xmlns:r="http://schemas.openxmlformats.org/officeDocument/2006/relationships" xmlns:p="http://schemas.openxmlformats.org/presentationml/2006/main">
   <p:cSld>
     <p:spTree>
@@ -3390,7 +3657,7 @@
           <a:p>
             <a:fld id="{F7021451-1387-4CA6-816F-3879F97B5CBC}" type="slidenum">
               <a:rPr lang="en-US"/>
-              <a:t>39</a:t>
+              <a:t>41</a:t>
             </a:fld>
             <a:endParaRPr lang="en-US"/>
           </a:p>
@@ -3409,7 +3676,7 @@
 </p:notes>
 </file>
 
-<file path=ppt/notesSlides/notesSlide4.xml><?xml version="1.0" encoding="utf-8"?>
+<file path=ppt/notesSlides/notesSlide42.xml><?xml version="1.0" encoding="utf-8"?>
 <p:notes xmlns:a="http://schemas.openxmlformats.org/drawingml/2006/main" xmlns:r="http://schemas.openxmlformats.org/officeDocument/2006/relationships" xmlns:p="http://schemas.openxmlformats.org/presentationml/2006/main">
   <p:cSld>
     <p:spTree>
@@ -3478,7 +3745,7 @@
           <a:p>
             <a:fld id="{F7021451-1387-4CA6-816F-3879F97B5CBC}" type="slidenum">
               <a:rPr lang="en-US"/>
-              <a:t>4</a:t>
+              <a:t>42</a:t>
             </a:fld>
             <a:endParaRPr lang="en-US"/>
           </a:p>
@@ -3497,7 +3764,7 @@
 </p:notes>
 </file>
 
-<file path=ppt/notesSlides/notesSlide40.xml><?xml version="1.0" encoding="utf-8"?>
+<file path=ppt/notesSlides/notesSlide43.xml><?xml version="1.0" encoding="utf-8"?>
 <p:notes xmlns:a="http://schemas.openxmlformats.org/drawingml/2006/main" xmlns:r="http://schemas.openxmlformats.org/officeDocument/2006/relationships" xmlns:p="http://schemas.openxmlformats.org/presentationml/2006/main">
   <p:cSld>
     <p:spTree>
@@ -3566,7 +3833,7 @@
           <a:p>
             <a:fld id="{F7021451-1387-4CA6-816F-3879F97B5CBC}" type="slidenum">
               <a:rPr lang="en-US"/>
-              <a:t>40</a:t>
+              <a:t>43</a:t>
             </a:fld>
             <a:endParaRPr lang="en-US"/>
           </a:p>
@@ -3585,7 +3852,7 @@
 </p:notes>
 </file>
 
-<file path=ppt/notesSlides/notesSlide41.xml><?xml version="1.0" encoding="utf-8"?>
+<file path=ppt/notesSlides/notesSlide44.xml><?xml version="1.0" encoding="utf-8"?>
 <p:notes xmlns:a="http://schemas.openxmlformats.org/drawingml/2006/main" xmlns:r="http://schemas.openxmlformats.org/officeDocument/2006/relationships" xmlns:p="http://schemas.openxmlformats.org/presentationml/2006/main">
   <p:cSld>
     <p:spTree>
@@ -3654,7 +3921,7 @@
           <a:p>
             <a:fld id="{F7021451-1387-4CA6-816F-3879F97B5CBC}" type="slidenum">
               <a:rPr lang="en-US"/>
-              <a:t>41</a:t>
+              <a:t>44</a:t>
             </a:fld>
             <a:endParaRPr lang="en-US"/>
           </a:p>
@@ -3673,7 +3940,7 @@
 </p:notes>
 </file>
 
-<file path=ppt/notesSlides/notesSlide42.xml><?xml version="1.0" encoding="utf-8"?>
+<file path=ppt/notesSlides/notesSlide5.xml><?xml version="1.0" encoding="utf-8"?>
 <p:notes xmlns:a="http://schemas.openxmlformats.org/drawingml/2006/main" xmlns:r="http://schemas.openxmlformats.org/officeDocument/2006/relationships" xmlns:p="http://schemas.openxmlformats.org/presentationml/2006/main">
   <p:cSld>
     <p:spTree>
@@ -3742,7 +4009,7 @@
           <a:p>
             <a:fld id="{F7021451-1387-4CA6-816F-3879F97B5CBC}" type="slidenum">
               <a:rPr lang="en-US"/>
-              <a:t>42</a:t>
+              <a:t>5</a:t>
             </a:fld>
             <a:endParaRPr lang="en-US"/>
           </a:p>
@@ -3761,7 +4028,7 @@
 </p:notes>
 </file>
 
-<file path=ppt/notesSlides/notesSlide5.xml><?xml version="1.0" encoding="utf-8"?>
+<file path=ppt/notesSlides/notesSlide6.xml><?xml version="1.0" encoding="utf-8"?>
 <p:notes xmlns:a="http://schemas.openxmlformats.org/drawingml/2006/main" xmlns:r="http://schemas.openxmlformats.org/officeDocument/2006/relationships" xmlns:p="http://schemas.openxmlformats.org/presentationml/2006/main">
   <p:cSld>
     <p:spTree>
@@ -3830,7 +4097,7 @@
           <a:p>
             <a:fld id="{F7021451-1387-4CA6-816F-3879F97B5CBC}" type="slidenum">
               <a:rPr lang="en-US"/>
-              <a:t>5</a:t>
+              <a:t>6</a:t>
             </a:fld>
             <a:endParaRPr lang="en-US"/>
           </a:p>
@@ -3849,7 +4116,7 @@
 </p:notes>
 </file>
 
-<file path=ppt/notesSlides/notesSlide6.xml><?xml version="1.0" encoding="utf-8"?>
+<file path=ppt/notesSlides/notesSlide7.xml><?xml version="1.0" encoding="utf-8"?>
 <p:notes xmlns:a="http://schemas.openxmlformats.org/drawingml/2006/main" xmlns:r="http://schemas.openxmlformats.org/officeDocument/2006/relationships" xmlns:p="http://schemas.openxmlformats.org/presentationml/2006/main">
   <p:cSld>
     <p:spTree>
@@ -3918,7 +4185,7 @@
           <a:p>
             <a:fld id="{F7021451-1387-4CA6-816F-3879F97B5CBC}" type="slidenum">
               <a:rPr lang="en-US"/>
-              <a:t>6</a:t>
+              <a:t>7</a:t>
             </a:fld>
             <a:endParaRPr lang="en-US"/>
           </a:p>
@@ -3937,7 +4204,7 @@
 </p:notes>
 </file>
 
-<file path=ppt/notesSlides/notesSlide7.xml><?xml version="1.0" encoding="utf-8"?>
+<file path=ppt/notesSlides/notesSlide8.xml><?xml version="1.0" encoding="utf-8"?>
 <p:notes xmlns:a="http://schemas.openxmlformats.org/drawingml/2006/main" xmlns:r="http://schemas.openxmlformats.org/officeDocument/2006/relationships" xmlns:p="http://schemas.openxmlformats.org/presentationml/2006/main">
   <p:cSld>
     <p:spTree>
@@ -3985,94 +4252,6 @@
               <a:rPr lang="en-US" dirty="0"/>
               <a:t>Same function. Verbose costs 4× more.
 Not "more informative" — more expensive and more distracting.</a:t>
-            </a:r>
-            <a:endParaRPr lang="en-US" dirty="0"/>
-          </a:p>
-        </p:txBody>
-      </p:sp>
-      <p:sp>
-        <p:nvSpPr>
-          <p:cNvPr id="4" name="Slide Number Placeholder 3"/>
-          <p:cNvSpPr>
-            <a:spLocks noGrp="1"/>
-          </p:cNvSpPr>
-          <p:nvPr>
-            <p:ph type="sldNum" sz="quarter" idx="10"/>
-          </p:nvPr>
-        </p:nvSpPr>
-        <p:spPr/>
-        <p:txBody>
-          <a:bodyPr/>
-          <a:lstStyle/>
-          <a:p>
-            <a:fld id="{F7021451-1387-4CA6-816F-3879F97B5CBC}" type="slidenum">
-              <a:rPr lang="en-US"/>
-              <a:t>7</a:t>
-            </a:fld>
-            <a:endParaRPr lang="en-US"/>
-          </a:p>
-        </p:txBody>
-      </p:sp>
-    </p:spTree>
-    <p:extLst>
-      <p:ext uri="{BB962C8B-B14F-4D97-AF65-F5344CB8AC3E}">
-        <p14:creationId xmlns:p14="http://schemas.microsoft.com/office/powerpoint/2010/main" val="1024086991"/>
-      </p:ext>
-    </p:extLst>
-  </p:cSld>
-  <p:clrMapOvr>
-    <a:masterClrMapping/>
-  </p:clrMapOvr>
-</p:notes>
-</file>
-
-<file path=ppt/notesSlides/notesSlide8.xml><?xml version="1.0" encoding="utf-8"?>
-<p:notes xmlns:a="http://schemas.openxmlformats.org/drawingml/2006/main" xmlns:r="http://schemas.openxmlformats.org/officeDocument/2006/relationships" xmlns:p="http://schemas.openxmlformats.org/presentationml/2006/main">
-  <p:cSld>
-    <p:spTree>
-      <p:nvGrpSpPr>
-        <p:cNvPr id="1" name=""/>
-        <p:cNvGrpSpPr/>
-        <p:nvPr/>
-      </p:nvGrpSpPr>
-      <p:grpSpPr>
-        <a:xfrm>
-          <a:off x="0" y="0"/>
-          <a:ext cx="0" cy="0"/>
-          <a:chOff x="0" y="0"/>
-          <a:chExt cx="0" cy="0"/>
-        </a:xfrm>
-      </p:grpSpPr>
-      <p:sp>
-        <p:nvSpPr>
-          <p:cNvPr id="2" name="Slide Image Placeholder 1"/>
-          <p:cNvSpPr>
-            <a:spLocks noGrp="1" noRot="1" noChangeAspect="1"/>
-          </p:cNvSpPr>
-          <p:nvPr>
-            <p:ph type="sldImg"/>
-          </p:nvPr>
-        </p:nvSpPr>
-        <p:spPr/>
-      </p:sp>
-      <p:sp>
-        <p:nvSpPr>
-          <p:cNvPr id="3" name="Notes Placeholder 2"/>
-          <p:cNvSpPr>
-            <a:spLocks noGrp="1"/>
-          </p:cNvSpPr>
-          <p:nvPr>
-            <p:ph type="body" idx="1"/>
-          </p:nvPr>
-        </p:nvSpPr>
-        <p:spPr/>
-        <p:txBody>
-          <a:bodyPr/>
-          <a:lstStyle/>
-          <a:p>
-            <a:r>
-              <a:rPr lang="en-US" dirty="0"/>
-              <a:t/>
             </a:r>
             <a:endParaRPr lang="en-US" dirty="0"/>
           </a:p>
@@ -5916,6 +6095,84 @@
 <file path=ppt/slides/slide42.xml><?xml version="1.0" encoding="utf-8"?>
 <p:sld xmlns:a="http://schemas.openxmlformats.org/drawingml/2006/main" xmlns:r="http://schemas.openxmlformats.org/officeDocument/2006/relationships" xmlns:p="http://schemas.openxmlformats.org/presentationml/2006/main">
   <p:cSld name="Slide 42">
+    <p:bg>
+      <p:bgPr>
+        <a:blipFill dpi="0" rotWithShape="1">
+          <a:blip r:embed="rId1">
+            <a:lum/>
+          </a:blip>
+          <a:srcRect/>
+          <a:stretch>
+            <a:fillRect/>
+          </a:stretch>
+        </a:blipFill>
+        <a:effectLst/>
+      </p:bgPr>
+    </p:bg>
+    <p:spTree>
+      <p:nvGrpSpPr>
+        <p:cNvPr id="1" name=""/>
+        <p:cNvGrpSpPr/>
+        <p:nvPr/>
+      </p:nvGrpSpPr>
+      <p:grpSpPr>
+        <a:xfrm>
+          <a:off x="0" y="0"/>
+          <a:ext cx="0" cy="0"/>
+          <a:chOff x="0" y="0"/>
+          <a:chExt cx="0" cy="0"/>
+        </a:xfrm>
+      </p:grpSpPr>
+    </p:spTree>
+  </p:cSld>
+  <p:clrMapOvr>
+    <a:masterClrMapping/>
+  </p:clrMapOvr>
+</p:sld>
+</file>
+
+<file path=ppt/slides/slide43.xml><?xml version="1.0" encoding="utf-8"?>
+<p:sld xmlns:a="http://schemas.openxmlformats.org/drawingml/2006/main" xmlns:r="http://schemas.openxmlformats.org/officeDocument/2006/relationships" xmlns:p="http://schemas.openxmlformats.org/presentationml/2006/main">
+  <p:cSld name="Slide 43">
+    <p:bg>
+      <p:bgPr>
+        <a:blipFill dpi="0" rotWithShape="1">
+          <a:blip r:embed="rId1">
+            <a:lum/>
+          </a:blip>
+          <a:srcRect/>
+          <a:stretch>
+            <a:fillRect/>
+          </a:stretch>
+        </a:blipFill>
+        <a:effectLst/>
+      </p:bgPr>
+    </p:bg>
+    <p:spTree>
+      <p:nvGrpSpPr>
+        <p:cNvPr id="1" name=""/>
+        <p:cNvGrpSpPr/>
+        <p:nvPr/>
+      </p:nvGrpSpPr>
+      <p:grpSpPr>
+        <a:xfrm>
+          <a:off x="0" y="0"/>
+          <a:ext cx="0" cy="0"/>
+          <a:chOff x="0" y="0"/>
+          <a:chExt cx="0" cy="0"/>
+        </a:xfrm>
+      </p:grpSpPr>
+    </p:spTree>
+  </p:cSld>
+  <p:clrMapOvr>
+    <a:masterClrMapping/>
+  </p:clrMapOvr>
+</p:sld>
+</file>
+
+<file path=ppt/slides/slide44.xml><?xml version="1.0" encoding="utf-8"?>
+<p:sld xmlns:a="http://schemas.openxmlformats.org/drawingml/2006/main" xmlns:r="http://schemas.openxmlformats.org/officeDocument/2006/relationships" xmlns:p="http://schemas.openxmlformats.org/presentationml/2006/main">
+  <p:cSld name="Slide 44">
     <p:bg>
       <p:bgPr>
         <a:blipFill dpi="0" rotWithShape="1">

</xml_diff>

<commit_message>
L02: republish with the attention diagram and the frontier correction
The ladder slide implied students get access to a frontier model, which
they do not. A new slide draws one step of attention, which the deck had
only asserted. The three repeated "next lecture" closes are now one.
31 slides to 32.

https://claude.ai/code/session_01Nac3M9CHSMSmoRnkHhPjB1
</commit_message>
<xml_diff>
--- a/lectures/L02/slides.pptx
+++ b/lectures/L02/slides.pptx
@@ -49,9 +49,10 @@
     <p:sldId id="297" r:id="rId43"/>
     <p:sldId id="298" r:id="rId44"/>
     <p:sldId id="299" r:id="rId45"/>
+    <p:sldId id="300" r:id="rId46"/>
   </p:sldIdLst>
   <p:notesMasterIdLst>
-    <p:notesMasterId r:id="rId46"/>
+    <p:notesMasterId r:id="rId47"/>
   </p:notesMasterIdLst>
   <p:sldSz cx="9334500" cy="5248275"/>
   <p:notesSz cx="5248275" cy="9334500"/>
@@ -810,8 +811,11 @@
           <a:p>
             <a:r>
               <a:rPr lang="en-US" dirty="0"/>
-              <a:t>The number to land: 32× the text is not 32× the cost, it is 1000×.
-This is why "just paste the repo in" fails on a laptop.</a:t>
+              <a:t>Walk it: the model is choosing what follows "httpx." and to do that it
+scores every token already in the window, not just the nearby ones.
+Thickness is attention weight. Then the setup for the next slide: this
+whole picture happens again for the token after "get", and again after
+that.</a:t>
             </a:r>
             <a:endParaRPr lang="en-US" dirty="0"/>
           </a:p>
@@ -899,7 +903,8 @@
           <a:p>
             <a:r>
               <a:rPr lang="en-US" dirty="0"/>
-              <a:t/>
+              <a:t>The number to land: 32× the text is not 32× the cost, it is 1000×.
+This is why "just paste the repo in" fails on a laptop.</a:t>
             </a:r>
             <a:endParaRPr lang="en-US" dirty="0"/>
           </a:p>
@@ -1030,6 +1035,94 @@
 </file>
 
 <file path=ppt/notesSlides/notesSlide15.xml><?xml version="1.0" encoding="utf-8"?>
+<p:notes xmlns:a="http://schemas.openxmlformats.org/drawingml/2006/main" xmlns:r="http://schemas.openxmlformats.org/officeDocument/2006/relationships" xmlns:p="http://schemas.openxmlformats.org/presentationml/2006/main">
+  <p:cSld>
+    <p:spTree>
+      <p:nvGrpSpPr>
+        <p:cNvPr id="1" name=""/>
+        <p:cNvGrpSpPr/>
+        <p:nvPr/>
+      </p:nvGrpSpPr>
+      <p:grpSpPr>
+        <a:xfrm>
+          <a:off x="0" y="0"/>
+          <a:ext cx="0" cy="0"/>
+          <a:chOff x="0" y="0"/>
+          <a:chExt cx="0" cy="0"/>
+        </a:xfrm>
+      </p:grpSpPr>
+      <p:sp>
+        <p:nvSpPr>
+          <p:cNvPr id="2" name="Slide Image Placeholder 1"/>
+          <p:cNvSpPr>
+            <a:spLocks noGrp="1" noRot="1" noChangeAspect="1"/>
+          </p:cNvSpPr>
+          <p:nvPr>
+            <p:ph type="sldImg"/>
+          </p:nvPr>
+        </p:nvSpPr>
+        <p:spPr/>
+      </p:sp>
+      <p:sp>
+        <p:nvSpPr>
+          <p:cNvPr id="3" name="Notes Placeholder 2"/>
+          <p:cNvSpPr>
+            <a:spLocks noGrp="1"/>
+          </p:cNvSpPr>
+          <p:nvPr>
+            <p:ph type="body" idx="1"/>
+          </p:nvPr>
+        </p:nvSpPr>
+        <p:spPr/>
+        <p:txBody>
+          <a:bodyPr/>
+          <a:lstStyle/>
+          <a:p>
+            <a:r>
+              <a:rPr lang="en-US" dirty="0"/>
+              <a:t/>
+            </a:r>
+            <a:endParaRPr lang="en-US" dirty="0"/>
+          </a:p>
+        </p:txBody>
+      </p:sp>
+      <p:sp>
+        <p:nvSpPr>
+          <p:cNvPr id="4" name="Slide Number Placeholder 3"/>
+          <p:cNvSpPr>
+            <a:spLocks noGrp="1"/>
+          </p:cNvSpPr>
+          <p:nvPr>
+            <p:ph type="sldNum" sz="quarter" idx="10"/>
+          </p:nvPr>
+        </p:nvSpPr>
+        <p:spPr/>
+        <p:txBody>
+          <a:bodyPr/>
+          <a:lstStyle/>
+          <a:p>
+            <a:fld id="{F7021451-1387-4CA6-816F-3879F97B5CBC}" type="slidenum">
+              <a:rPr lang="en-US"/>
+              <a:t>15</a:t>
+            </a:fld>
+            <a:endParaRPr lang="en-US"/>
+          </a:p>
+        </p:txBody>
+      </p:sp>
+    </p:spTree>
+    <p:extLst>
+      <p:ext uri="{BB962C8B-B14F-4D97-AF65-F5344CB8AC3E}">
+        <p14:creationId xmlns:p14="http://schemas.microsoft.com/office/powerpoint/2010/main" val="1024086991"/>
+      </p:ext>
+    </p:extLst>
+  </p:cSld>
+  <p:clrMapOvr>
+    <a:masterClrMapping/>
+  </p:clrMapOvr>
+</p:notes>
+</file>
+
+<file path=ppt/notesSlides/notesSlide16.xml><?xml version="1.0" encoding="utf-8"?>
 <p:notes xmlns:a="http://schemas.openxmlformats.org/drawingml/2006/main" xmlns:r="http://schemas.openxmlformats.org/officeDocument/2006/relationships" xmlns:p="http://schemas.openxmlformats.org/presentationml/2006/main">
   <p:cSld>
     <p:spTree>
@@ -1103,7 +1196,7 @@
           <a:p>
             <a:fld id="{F7021451-1387-4CA6-816F-3879F97B5CBC}" type="slidenum">
               <a:rPr lang="en-US"/>
-              <a:t>15</a:t>
+              <a:t>16</a:t>
             </a:fld>
             <a:endParaRPr lang="en-US"/>
           </a:p>
@@ -1122,7 +1215,7 @@
 </p:notes>
 </file>
 
-<file path=ppt/notesSlides/notesSlide16.xml><?xml version="1.0" encoding="utf-8"?>
+<file path=ppt/notesSlides/notesSlide17.xml><?xml version="1.0" encoding="utf-8"?>
 <p:notes xmlns:a="http://schemas.openxmlformats.org/drawingml/2006/main" xmlns:r="http://schemas.openxmlformats.org/officeDocument/2006/relationships" xmlns:p="http://schemas.openxmlformats.org/presentationml/2006/main">
   <p:cSld>
     <p:spTree>
@@ -1191,7 +1284,7 @@
           <a:p>
             <a:fld id="{F7021451-1387-4CA6-816F-3879F97B5CBC}" type="slidenum">
               <a:rPr lang="en-US"/>
-              <a:t>16</a:t>
+              <a:t>17</a:t>
             </a:fld>
             <a:endParaRPr lang="en-US"/>
           </a:p>
@@ -1210,7 +1303,7 @@
 </p:notes>
 </file>
 
-<file path=ppt/notesSlides/notesSlide17.xml><?xml version="1.0" encoding="utf-8"?>
+<file path=ppt/notesSlides/notesSlide18.xml><?xml version="1.0" encoding="utf-8"?>
 <p:notes xmlns:a="http://schemas.openxmlformats.org/drawingml/2006/main" xmlns:r="http://schemas.openxmlformats.org/officeDocument/2006/relationships" xmlns:p="http://schemas.openxmlformats.org/presentationml/2006/main">
   <p:cSld>
     <p:spTree>
@@ -1279,7 +1372,7 @@
           <a:p>
             <a:fld id="{F7021451-1387-4CA6-816F-3879F97B5CBC}" type="slidenum">
               <a:rPr lang="en-US"/>
-              <a:t>17</a:t>
+              <a:t>18</a:t>
             </a:fld>
             <a:endParaRPr lang="en-US"/>
           </a:p>
@@ -1298,7 +1391,7 @@
 </p:notes>
 </file>
 
-<file path=ppt/notesSlides/notesSlide18.xml><?xml version="1.0" encoding="utf-8"?>
+<file path=ppt/notesSlides/notesSlide19.xml><?xml version="1.0" encoding="utf-8"?>
 <p:notes xmlns:a="http://schemas.openxmlformats.org/drawingml/2006/main" xmlns:r="http://schemas.openxmlformats.org/officeDocument/2006/relationships" xmlns:p="http://schemas.openxmlformats.org/presentationml/2006/main">
   <p:cSld>
     <p:spTree>
@@ -1367,7 +1460,7 @@
           <a:p>
             <a:fld id="{F7021451-1387-4CA6-816F-3879F97B5CBC}" type="slidenum">
               <a:rPr lang="en-US"/>
-              <a:t>18</a:t>
+              <a:t>19</a:t>
             </a:fld>
             <a:endParaRPr lang="en-US"/>
           </a:p>
@@ -1386,7 +1479,95 @@
 </p:notes>
 </file>
 
-<file path=ppt/notesSlides/notesSlide19.xml><?xml version="1.0" encoding="utf-8"?>
+<file path=ppt/notesSlides/notesSlide2.xml><?xml version="1.0" encoding="utf-8"?>
+<p:notes xmlns:a="http://schemas.openxmlformats.org/drawingml/2006/main" xmlns:r="http://schemas.openxmlformats.org/officeDocument/2006/relationships" xmlns:p="http://schemas.openxmlformats.org/presentationml/2006/main">
+  <p:cSld>
+    <p:spTree>
+      <p:nvGrpSpPr>
+        <p:cNvPr id="1" name=""/>
+        <p:cNvGrpSpPr/>
+        <p:nvPr/>
+      </p:nvGrpSpPr>
+      <p:grpSpPr>
+        <a:xfrm>
+          <a:off x="0" y="0"/>
+          <a:ext cx="0" cy="0"/>
+          <a:chOff x="0" y="0"/>
+          <a:chExt cx="0" cy="0"/>
+        </a:xfrm>
+      </p:grpSpPr>
+      <p:sp>
+        <p:nvSpPr>
+          <p:cNvPr id="2" name="Slide Image Placeholder 1"/>
+          <p:cNvSpPr>
+            <a:spLocks noGrp="1" noRot="1" noChangeAspect="1"/>
+          </p:cNvSpPr>
+          <p:nvPr>
+            <p:ph type="sldImg"/>
+          </p:nvPr>
+        </p:nvSpPr>
+        <p:spPr/>
+      </p:sp>
+      <p:sp>
+        <p:nvSpPr>
+          <p:cNvPr id="3" name="Notes Placeholder 2"/>
+          <p:cNvSpPr>
+            <a:spLocks noGrp="1"/>
+          </p:cNvSpPr>
+          <p:nvPr>
+            <p:ph type="body" idx="1"/>
+          </p:nvPr>
+        </p:nvSpPr>
+        <p:spPr/>
+        <p:txBody>
+          <a:bodyPr/>
+          <a:lstStyle/>
+          <a:p>
+            <a:r>
+              <a:rPr lang="en-US" dirty="0"/>
+              <a:t>The opener: why bother with theory. When it doesn't work, mental models win.</a:t>
+            </a:r>
+            <a:endParaRPr lang="en-US" dirty="0"/>
+          </a:p>
+        </p:txBody>
+      </p:sp>
+      <p:sp>
+        <p:nvSpPr>
+          <p:cNvPr id="4" name="Slide Number Placeholder 3"/>
+          <p:cNvSpPr>
+            <a:spLocks noGrp="1"/>
+          </p:cNvSpPr>
+          <p:nvPr>
+            <p:ph type="sldNum" sz="quarter" idx="10"/>
+          </p:nvPr>
+        </p:nvSpPr>
+        <p:spPr/>
+        <p:txBody>
+          <a:bodyPr/>
+          <a:lstStyle/>
+          <a:p>
+            <a:fld id="{F7021451-1387-4CA6-816F-3879F97B5CBC}" type="slidenum">
+              <a:rPr lang="en-US"/>
+              <a:t>2</a:t>
+            </a:fld>
+            <a:endParaRPr lang="en-US"/>
+          </a:p>
+        </p:txBody>
+      </p:sp>
+    </p:spTree>
+    <p:extLst>
+      <p:ext uri="{BB962C8B-B14F-4D97-AF65-F5344CB8AC3E}">
+        <p14:creationId xmlns:p14="http://schemas.microsoft.com/office/powerpoint/2010/main" val="1024086991"/>
+      </p:ext>
+    </p:extLst>
+  </p:cSld>
+  <p:clrMapOvr>
+    <a:masterClrMapping/>
+  </p:clrMapOvr>
+</p:notes>
+</file>
+
+<file path=ppt/notesSlides/notesSlide20.xml><?xml version="1.0" encoding="utf-8"?>
 <p:notes xmlns:a="http://schemas.openxmlformats.org/drawingml/2006/main" xmlns:r="http://schemas.openxmlformats.org/officeDocument/2006/relationships" xmlns:p="http://schemas.openxmlformats.org/presentationml/2006/main">
   <p:cSld>
     <p:spTree>
@@ -1455,7 +1636,7 @@
           <a:p>
             <a:fld id="{F7021451-1387-4CA6-816F-3879F97B5CBC}" type="slidenum">
               <a:rPr lang="en-US"/>
-              <a:t>19</a:t>
+              <a:t>20</a:t>
             </a:fld>
             <a:endParaRPr lang="en-US"/>
           </a:p>
@@ -1474,7 +1655,7 @@
 </p:notes>
 </file>
 
-<file path=ppt/notesSlides/notesSlide2.xml><?xml version="1.0" encoding="utf-8"?>
+<file path=ppt/notesSlides/notesSlide21.xml><?xml version="1.0" encoding="utf-8"?>
 <p:notes xmlns:a="http://schemas.openxmlformats.org/drawingml/2006/main" xmlns:r="http://schemas.openxmlformats.org/officeDocument/2006/relationships" xmlns:p="http://schemas.openxmlformats.org/presentationml/2006/main">
   <p:cSld>
     <p:spTree>
@@ -1520,7 +1701,7 @@
           <a:p>
             <a:r>
               <a:rPr lang="en-US" dirty="0"/>
-              <a:t>The opener: why bother with theory. When it doesn't work, mental models win.</a:t>
+              <a:t>"Hallucination" sounds like a mistake. It's not a mistake — it's the design.</a:t>
             </a:r>
             <a:endParaRPr lang="en-US" dirty="0"/>
           </a:p>
@@ -1543,7 +1724,7 @@
           <a:p>
             <a:fld id="{F7021451-1387-4CA6-816F-3879F97B5CBC}" type="slidenum">
               <a:rPr lang="en-US"/>
-              <a:t>2</a:t>
+              <a:t>21</a:t>
             </a:fld>
             <a:endParaRPr lang="en-US"/>
           </a:p>
@@ -1562,7 +1743,7 @@
 </p:notes>
 </file>
 
-<file path=ppt/notesSlides/notesSlide20.xml><?xml version="1.0" encoding="utf-8"?>
+<file path=ppt/notesSlides/notesSlide22.xml><?xml version="1.0" encoding="utf-8"?>
 <p:notes xmlns:a="http://schemas.openxmlformats.org/drawingml/2006/main" xmlns:r="http://schemas.openxmlformats.org/officeDocument/2006/relationships" xmlns:p="http://schemas.openxmlformats.org/presentationml/2006/main">
   <p:cSld>
     <p:spTree>
@@ -1631,7 +1812,7 @@
           <a:p>
             <a:fld id="{F7021451-1387-4CA6-816F-3879F97B5CBC}" type="slidenum">
               <a:rPr lang="en-US"/>
-              <a:t>20</a:t>
+              <a:t>22</a:t>
             </a:fld>
             <a:endParaRPr lang="en-US"/>
           </a:p>
@@ -1650,7 +1831,7 @@
 </p:notes>
 </file>
 
-<file path=ppt/notesSlides/notesSlide21.xml><?xml version="1.0" encoding="utf-8"?>
+<file path=ppt/notesSlides/notesSlide23.xml><?xml version="1.0" encoding="utf-8"?>
 <p:notes xmlns:a="http://schemas.openxmlformats.org/drawingml/2006/main" xmlns:r="http://schemas.openxmlformats.org/officeDocument/2006/relationships" xmlns:p="http://schemas.openxmlformats.org/presentationml/2006/main">
   <p:cSld>
     <p:spTree>
@@ -1719,7 +1900,7 @@
           <a:p>
             <a:fld id="{F7021451-1387-4CA6-816F-3879F97B5CBC}" type="slidenum">
               <a:rPr lang="en-US"/>
-              <a:t>21</a:t>
+              <a:t>23</a:t>
             </a:fld>
             <a:endParaRPr lang="en-US"/>
           </a:p>
@@ -1738,7 +1919,7 @@
 </p:notes>
 </file>
 
-<file path=ppt/notesSlides/notesSlide22.xml><?xml version="1.0" encoding="utf-8"?>
+<file path=ppt/notesSlides/notesSlide24.xml><?xml version="1.0" encoding="utf-8"?>
 <p:notes xmlns:a="http://schemas.openxmlformats.org/drawingml/2006/main" xmlns:r="http://schemas.openxmlformats.org/officeDocument/2006/relationships" xmlns:p="http://schemas.openxmlformats.org/presentationml/2006/main">
   <p:cSld>
     <p:spTree>
@@ -1784,7 +1965,7 @@
           <a:p>
             <a:r>
               <a:rPr lang="en-US" dirty="0"/>
-              <a:t>"Hallucination" sounds like a mistake. It's not a mistake — it's the design.</a:t>
+              <a:t>Not "made up" — wrong real library for the wrong real project.</a:t>
             </a:r>
             <a:endParaRPr lang="en-US" dirty="0"/>
           </a:p>
@@ -1807,7 +1988,7 @@
           <a:p>
             <a:fld id="{F7021451-1387-4CA6-816F-3879F97B5CBC}" type="slidenum">
               <a:rPr lang="en-US"/>
-              <a:t>22</a:t>
+              <a:t>24</a:t>
             </a:fld>
             <a:endParaRPr lang="en-US"/>
           </a:p>
@@ -1826,7 +2007,7 @@
 </p:notes>
 </file>
 
-<file path=ppt/notesSlides/notesSlide23.xml><?xml version="1.0" encoding="utf-8"?>
+<file path=ppt/notesSlides/notesSlide25.xml><?xml version="1.0" encoding="utf-8"?>
 <p:notes xmlns:a="http://schemas.openxmlformats.org/drawingml/2006/main" xmlns:r="http://schemas.openxmlformats.org/officeDocument/2006/relationships" xmlns:p="http://schemas.openxmlformats.org/presentationml/2006/main">
   <p:cSld>
     <p:spTree>
@@ -1895,7 +2076,7 @@
           <a:p>
             <a:fld id="{F7021451-1387-4CA6-816F-3879F97B5CBC}" type="slidenum">
               <a:rPr lang="en-US"/>
-              <a:t>23</a:t>
+              <a:t>25</a:t>
             </a:fld>
             <a:endParaRPr lang="en-US"/>
           </a:p>
@@ -1914,7 +2095,7 @@
 </p:notes>
 </file>
 
-<file path=ppt/notesSlides/notesSlide24.xml><?xml version="1.0" encoding="utf-8"?>
+<file path=ppt/notesSlides/notesSlide26.xml><?xml version="1.0" encoding="utf-8"?>
 <p:notes xmlns:a="http://schemas.openxmlformats.org/drawingml/2006/main" xmlns:r="http://schemas.openxmlformats.org/officeDocument/2006/relationships" xmlns:p="http://schemas.openxmlformats.org/presentationml/2006/main">
   <p:cSld>
     <p:spTree>
@@ -1983,7 +2164,7 @@
           <a:p>
             <a:fld id="{F7021451-1387-4CA6-816F-3879F97B5CBC}" type="slidenum">
               <a:rPr lang="en-US"/>
-              <a:t>24</a:t>
+              <a:t>26</a:t>
             </a:fld>
             <a:endParaRPr lang="en-US"/>
           </a:p>
@@ -2002,7 +2183,7 @@
 </p:notes>
 </file>
 
-<file path=ppt/notesSlides/notesSlide25.xml><?xml version="1.0" encoding="utf-8"?>
+<file path=ppt/notesSlides/notesSlide27.xml><?xml version="1.0" encoding="utf-8"?>
 <p:notes xmlns:a="http://schemas.openxmlformats.org/drawingml/2006/main" xmlns:r="http://schemas.openxmlformats.org/officeDocument/2006/relationships" xmlns:p="http://schemas.openxmlformats.org/presentationml/2006/main">
   <p:cSld>
     <p:spTree>
@@ -2071,7 +2252,7 @@
           <a:p>
             <a:fld id="{F7021451-1387-4CA6-816F-3879F97B5CBC}" type="slidenum">
               <a:rPr lang="en-US"/>
-              <a:t>25</a:t>
+              <a:t>27</a:t>
             </a:fld>
             <a:endParaRPr lang="en-US"/>
           </a:p>
@@ -2090,7 +2271,7 @@
 </p:notes>
 </file>
 
-<file path=ppt/notesSlides/notesSlide26.xml><?xml version="1.0" encoding="utf-8"?>
+<file path=ppt/notesSlides/notesSlide28.xml><?xml version="1.0" encoding="utf-8"?>
 <p:notes xmlns:a="http://schemas.openxmlformats.org/drawingml/2006/main" xmlns:r="http://schemas.openxmlformats.org/officeDocument/2006/relationships" xmlns:p="http://schemas.openxmlformats.org/presentationml/2006/main">
   <p:cSld>
     <p:spTree>
@@ -2159,7 +2340,7 @@
           <a:p>
             <a:fld id="{F7021451-1387-4CA6-816F-3879F97B5CBC}" type="slidenum">
               <a:rPr lang="en-US"/>
-              <a:t>26</a:t>
+              <a:t>28</a:t>
             </a:fld>
             <a:endParaRPr lang="en-US"/>
           </a:p>
@@ -2178,7 +2359,7 @@
 </p:notes>
 </file>
 
-<file path=ppt/notesSlides/notesSlide27.xml><?xml version="1.0" encoding="utf-8"?>
+<file path=ppt/notesSlides/notesSlide29.xml><?xml version="1.0" encoding="utf-8"?>
 <p:notes xmlns:a="http://schemas.openxmlformats.org/drawingml/2006/main" xmlns:r="http://schemas.openxmlformats.org/officeDocument/2006/relationships" xmlns:p="http://schemas.openxmlformats.org/presentationml/2006/main">
   <p:cSld>
     <p:spTree>
@@ -2224,7 +2405,7 @@
           <a:p>
             <a:r>
               <a:rPr lang="en-US" dirty="0"/>
-              <a:t>Not "made up" — wrong real library for the wrong real project.</a:t>
+              <a:t/>
             </a:r>
             <a:endParaRPr lang="en-US" dirty="0"/>
           </a:p>
@@ -2247,7 +2428,7 @@
           <a:p>
             <a:fld id="{F7021451-1387-4CA6-816F-3879F97B5CBC}" type="slidenum">
               <a:rPr lang="en-US"/>
-              <a:t>27</a:t>
+              <a:t>29</a:t>
             </a:fld>
             <a:endParaRPr lang="en-US"/>
           </a:p>
@@ -2266,7 +2447,7 @@
 </p:notes>
 </file>
 
-<file path=ppt/notesSlides/notesSlide28.xml><?xml version="1.0" encoding="utf-8"?>
+<file path=ppt/notesSlides/notesSlide3.xml><?xml version="1.0" encoding="utf-8"?>
 <p:notes xmlns:a="http://schemas.openxmlformats.org/drawingml/2006/main" xmlns:r="http://schemas.openxmlformats.org/officeDocument/2006/relationships" xmlns:p="http://schemas.openxmlformats.org/presentationml/2006/main">
   <p:cSld>
     <p:spTree>
@@ -2335,7 +2516,7 @@
           <a:p>
             <a:fld id="{F7021451-1387-4CA6-816F-3879F97B5CBC}" type="slidenum">
               <a:rPr lang="en-US"/>
-              <a:t>28</a:t>
+              <a:t>3</a:t>
             </a:fld>
             <a:endParaRPr lang="en-US"/>
           </a:p>
@@ -2354,7 +2535,7 @@
 </p:notes>
 </file>
 
-<file path=ppt/notesSlides/notesSlide29.xml><?xml version="1.0" encoding="utf-8"?>
+<file path=ppt/notesSlides/notesSlide30.xml><?xml version="1.0" encoding="utf-8"?>
 <p:notes xmlns:a="http://schemas.openxmlformats.org/drawingml/2006/main" xmlns:r="http://schemas.openxmlformats.org/officeDocument/2006/relationships" xmlns:p="http://schemas.openxmlformats.org/presentationml/2006/main">
   <p:cSld>
     <p:spTree>
@@ -2423,7 +2604,7 @@
           <a:p>
             <a:fld id="{F7021451-1387-4CA6-816F-3879F97B5CBC}" type="slidenum">
               <a:rPr lang="en-US"/>
-              <a:t>29</a:t>
+              <a:t>30</a:t>
             </a:fld>
             <a:endParaRPr lang="en-US"/>
           </a:p>
@@ -2442,7 +2623,7 @@
 </p:notes>
 </file>
 
-<file path=ppt/notesSlides/notesSlide3.xml><?xml version="1.0" encoding="utf-8"?>
+<file path=ppt/notesSlides/notesSlide31.xml><?xml version="1.0" encoding="utf-8"?>
 <p:notes xmlns:a="http://schemas.openxmlformats.org/drawingml/2006/main" xmlns:r="http://schemas.openxmlformats.org/officeDocument/2006/relationships" xmlns:p="http://schemas.openxmlformats.org/presentationml/2006/main">
   <p:cSld>
     <p:spTree>
@@ -2511,7 +2692,7 @@
           <a:p>
             <a:fld id="{F7021451-1387-4CA6-816F-3879F97B5CBC}" type="slidenum">
               <a:rPr lang="en-US"/>
-              <a:t>3</a:t>
+              <a:t>31</a:t>
             </a:fld>
             <a:endParaRPr lang="en-US"/>
           </a:p>
@@ -2530,7 +2711,7 @@
 </p:notes>
 </file>
 
-<file path=ppt/notesSlides/notesSlide30.xml><?xml version="1.0" encoding="utf-8"?>
+<file path=ppt/notesSlides/notesSlide32.xml><?xml version="1.0" encoding="utf-8"?>
 <p:notes xmlns:a="http://schemas.openxmlformats.org/drawingml/2006/main" xmlns:r="http://schemas.openxmlformats.org/officeDocument/2006/relationships" xmlns:p="http://schemas.openxmlformats.org/presentationml/2006/main">
   <p:cSld>
     <p:spTree>
@@ -2599,7 +2780,7 @@
           <a:p>
             <a:fld id="{F7021451-1387-4CA6-816F-3879F97B5CBC}" type="slidenum">
               <a:rPr lang="en-US"/>
-              <a:t>30</a:t>
+              <a:t>32</a:t>
             </a:fld>
             <a:endParaRPr lang="en-US"/>
           </a:p>
@@ -2618,7 +2799,186 @@
 </p:notes>
 </file>
 
-<file path=ppt/notesSlides/notesSlide31.xml><?xml version="1.0" encoding="utf-8"?>
+<file path=ppt/notesSlides/notesSlide33.xml><?xml version="1.0" encoding="utf-8"?>
+<p:notes xmlns:a="http://schemas.openxmlformats.org/drawingml/2006/main" xmlns:r="http://schemas.openxmlformats.org/officeDocument/2006/relationships" xmlns:p="http://schemas.openxmlformats.org/presentationml/2006/main">
+  <p:cSld>
+    <p:spTree>
+      <p:nvGrpSpPr>
+        <p:cNvPr id="1" name=""/>
+        <p:cNvGrpSpPr/>
+        <p:nvPr/>
+      </p:nvGrpSpPr>
+      <p:grpSpPr>
+        <a:xfrm>
+          <a:off x="0" y="0"/>
+          <a:ext cx="0" cy="0"/>
+          <a:chOff x="0" y="0"/>
+          <a:chExt cx="0" cy="0"/>
+        </a:xfrm>
+      </p:grpSpPr>
+      <p:sp>
+        <p:nvSpPr>
+          <p:cNvPr id="2" name="Slide Image Placeholder 1"/>
+          <p:cNvSpPr>
+            <a:spLocks noGrp="1" noRot="1" noChangeAspect="1"/>
+          </p:cNvSpPr>
+          <p:nvPr>
+            <p:ph type="sldImg"/>
+          </p:nvPr>
+        </p:nvSpPr>
+        <p:spPr/>
+      </p:sp>
+      <p:sp>
+        <p:nvSpPr>
+          <p:cNvPr id="3" name="Notes Placeholder 2"/>
+          <p:cNvSpPr>
+            <a:spLocks noGrp="1"/>
+          </p:cNvSpPr>
+          <p:nvPr>
+            <p:ph type="body" idx="1"/>
+          </p:nvPr>
+        </p:nvSpPr>
+        <p:spPr/>
+        <p:txBody>
+          <a:bodyPr/>
+          <a:lstStyle/>
+          <a:p>
+            <a:r>
+              <a:rPr lang="en-US" dirty="0"/>
+              <a:t>Two axes. Confusing them = bad model choices.</a:t>
+            </a:r>
+            <a:endParaRPr lang="en-US" dirty="0"/>
+          </a:p>
+        </p:txBody>
+      </p:sp>
+      <p:sp>
+        <p:nvSpPr>
+          <p:cNvPr id="4" name="Slide Number Placeholder 3"/>
+          <p:cNvSpPr>
+            <a:spLocks noGrp="1"/>
+          </p:cNvSpPr>
+          <p:nvPr>
+            <p:ph type="sldNum" sz="quarter" idx="10"/>
+          </p:nvPr>
+        </p:nvSpPr>
+        <p:spPr/>
+        <p:txBody>
+          <a:bodyPr/>
+          <a:lstStyle/>
+          <a:p>
+            <a:fld id="{F7021451-1387-4CA6-816F-3879F97B5CBC}" type="slidenum">
+              <a:rPr lang="en-US"/>
+              <a:t>33</a:t>
+            </a:fld>
+            <a:endParaRPr lang="en-US"/>
+          </a:p>
+        </p:txBody>
+      </p:sp>
+    </p:spTree>
+    <p:extLst>
+      <p:ext uri="{BB962C8B-B14F-4D97-AF65-F5344CB8AC3E}">
+        <p14:creationId xmlns:p14="http://schemas.microsoft.com/office/powerpoint/2010/main" val="1024086991"/>
+      </p:ext>
+    </p:extLst>
+  </p:cSld>
+  <p:clrMapOvr>
+    <a:masterClrMapping/>
+  </p:clrMapOvr>
+</p:notes>
+</file>
+
+<file path=ppt/notesSlides/notesSlide34.xml><?xml version="1.0" encoding="utf-8"?>
+<p:notes xmlns:a="http://schemas.openxmlformats.org/drawingml/2006/main" xmlns:r="http://schemas.openxmlformats.org/officeDocument/2006/relationships" xmlns:p="http://schemas.openxmlformats.org/presentationml/2006/main">
+  <p:cSld>
+    <p:spTree>
+      <p:nvGrpSpPr>
+        <p:cNvPr id="1" name=""/>
+        <p:cNvGrpSpPr/>
+        <p:nvPr/>
+      </p:nvGrpSpPr>
+      <p:grpSpPr>
+        <a:xfrm>
+          <a:off x="0" y="0"/>
+          <a:ext cx="0" cy="0"/>
+          <a:chOff x="0" y="0"/>
+          <a:chExt cx="0" cy="0"/>
+        </a:xfrm>
+      </p:grpSpPr>
+      <p:sp>
+        <p:nvSpPr>
+          <p:cNvPr id="2" name="Slide Image Placeholder 1"/>
+          <p:cNvSpPr>
+            <a:spLocks noGrp="1" noRot="1" noChangeAspect="1"/>
+          </p:cNvSpPr>
+          <p:nvPr>
+            <p:ph type="sldImg"/>
+          </p:nvPr>
+        </p:nvSpPr>
+        <p:spPr/>
+      </p:sp>
+      <p:sp>
+        <p:nvSpPr>
+          <p:cNvPr id="3" name="Notes Placeholder 2"/>
+          <p:cNvSpPr>
+            <a:spLocks noGrp="1"/>
+          </p:cNvSpPr>
+          <p:nvPr>
+            <p:ph type="body" idx="1"/>
+          </p:nvPr>
+        </p:nvSpPr>
+        <p:spPr/>
+        <p:txBody>
+          <a:bodyPr/>
+          <a:lstStyle/>
+          <a:p>
+            <a:r>
+              <a:rPr lang="en-US" dirty="0"/>
+              <a:t>Don't assert this — promise the experiment. Everyone runs the same repo on
+4b and then 9b over the next two weeks. That beats any benchmark I could
+show. Be clear that frontier is the rung they are NOT on: it is here to
+name what they are giving up and why, not as something they get access to.</a:t>
+            </a:r>
+            <a:endParaRPr lang="en-US" dirty="0"/>
+          </a:p>
+        </p:txBody>
+      </p:sp>
+      <p:sp>
+        <p:nvSpPr>
+          <p:cNvPr id="4" name="Slide Number Placeholder 3"/>
+          <p:cNvSpPr>
+            <a:spLocks noGrp="1"/>
+          </p:cNvSpPr>
+          <p:nvPr>
+            <p:ph type="sldNum" sz="quarter" idx="10"/>
+          </p:nvPr>
+        </p:nvSpPr>
+        <p:spPr/>
+        <p:txBody>
+          <a:bodyPr/>
+          <a:lstStyle/>
+          <a:p>
+            <a:fld id="{F7021451-1387-4CA6-816F-3879F97B5CBC}" type="slidenum">
+              <a:rPr lang="en-US"/>
+              <a:t>34</a:t>
+            </a:fld>
+            <a:endParaRPr lang="en-US"/>
+          </a:p>
+        </p:txBody>
+      </p:sp>
+    </p:spTree>
+    <p:extLst>
+      <p:ext uri="{BB962C8B-B14F-4D97-AF65-F5344CB8AC3E}">
+        <p14:creationId xmlns:p14="http://schemas.microsoft.com/office/powerpoint/2010/main" val="1024086991"/>
+      </p:ext>
+    </p:extLst>
+  </p:cSld>
+  <p:clrMapOvr>
+    <a:masterClrMapping/>
+  </p:clrMapOvr>
+</p:notes>
+</file>
+
+<file path=ppt/notesSlides/notesSlide35.xml><?xml version="1.0" encoding="utf-8"?>
 <p:notes xmlns:a="http://schemas.openxmlformats.org/drawingml/2006/main" xmlns:r="http://schemas.openxmlformats.org/officeDocument/2006/relationships" xmlns:p="http://schemas.openxmlformats.org/presentationml/2006/main">
   <p:cSld>
     <p:spTree>
@@ -2687,7 +3047,7 @@
           <a:p>
             <a:fld id="{F7021451-1387-4CA6-816F-3879F97B5CBC}" type="slidenum">
               <a:rPr lang="en-US"/>
-              <a:t>31</a:t>
+              <a:t>35</a:t>
             </a:fld>
             <a:endParaRPr lang="en-US"/>
           </a:p>
@@ -2706,7 +3066,7 @@
 </p:notes>
 </file>
 
-<file path=ppt/notesSlides/notesSlide32.xml><?xml version="1.0" encoding="utf-8"?>
+<file path=ppt/notesSlides/notesSlide36.xml><?xml version="1.0" encoding="utf-8"?>
 <p:notes xmlns:a="http://schemas.openxmlformats.org/drawingml/2006/main" xmlns:r="http://schemas.openxmlformats.org/officeDocument/2006/relationships" xmlns:p="http://schemas.openxmlformats.org/presentationml/2006/main">
   <p:cSld>
     <p:spTree>
@@ -2752,7 +3112,7 @@
           <a:p>
             <a:r>
               <a:rPr lang="en-US" dirty="0"/>
-              <a:t>Two axes. Confusing them = bad model choices.</a:t>
+              <a:t/>
             </a:r>
             <a:endParaRPr lang="en-US" dirty="0"/>
           </a:p>
@@ -2775,7 +3135,7 @@
           <a:p>
             <a:fld id="{F7021451-1387-4CA6-816F-3879F97B5CBC}" type="slidenum">
               <a:rPr lang="en-US"/>
-              <a:t>32</a:t>
+              <a:t>36</a:t>
             </a:fld>
             <a:endParaRPr lang="en-US"/>
           </a:p>
@@ -2794,7 +3154,7 @@
 </p:notes>
 </file>
 
-<file path=ppt/notesSlides/notesSlide33.xml><?xml version="1.0" encoding="utf-8"?>
+<file path=ppt/notesSlides/notesSlide37.xml><?xml version="1.0" encoding="utf-8"?>
 <p:notes xmlns:a="http://schemas.openxmlformats.org/drawingml/2006/main" xmlns:r="http://schemas.openxmlformats.org/officeDocument/2006/relationships" xmlns:p="http://schemas.openxmlformats.org/presentationml/2006/main">
   <p:cSld>
     <p:spTree>
@@ -2840,8 +3200,7 @@
           <a:p>
             <a:r>
               <a:rPr lang="en-US" dirty="0"/>
-              <a:t>Don't assert this — promise the experiment. Everyone runs the same repo on
-both models over the next two weeks. That beats any benchmark I could show.</a:t>
+              <a:t/>
             </a:r>
             <a:endParaRPr lang="en-US" dirty="0"/>
           </a:p>
@@ -2864,7 +3223,7 @@
           <a:p>
             <a:fld id="{F7021451-1387-4CA6-816F-3879F97B5CBC}" type="slidenum">
               <a:rPr lang="en-US"/>
-              <a:t>33</a:t>
+              <a:t>37</a:t>
             </a:fld>
             <a:endParaRPr lang="en-US"/>
           </a:p>
@@ -2883,7 +3242,7 @@
 </p:notes>
 </file>
 
-<file path=ppt/notesSlides/notesSlide34.xml><?xml version="1.0" encoding="utf-8"?>
+<file path=ppt/notesSlides/notesSlide38.xml><?xml version="1.0" encoding="utf-8"?>
 <p:notes xmlns:a="http://schemas.openxmlformats.org/drawingml/2006/main" xmlns:r="http://schemas.openxmlformats.org/officeDocument/2006/relationships" xmlns:p="http://schemas.openxmlformats.org/presentationml/2006/main">
   <p:cSld>
     <p:spTree>
@@ -2952,7 +3311,7 @@
           <a:p>
             <a:fld id="{F7021451-1387-4CA6-816F-3879F97B5CBC}" type="slidenum">
               <a:rPr lang="en-US"/>
-              <a:t>34</a:t>
+              <a:t>38</a:t>
             </a:fld>
             <a:endParaRPr lang="en-US"/>
           </a:p>
@@ -2971,7 +3330,7 @@
 </p:notes>
 </file>
 
-<file path=ppt/notesSlides/notesSlide35.xml><?xml version="1.0" encoding="utf-8"?>
+<file path=ppt/notesSlides/notesSlide39.xml><?xml version="1.0" encoding="utf-8"?>
 <p:notes xmlns:a="http://schemas.openxmlformats.org/drawingml/2006/main" xmlns:r="http://schemas.openxmlformats.org/officeDocument/2006/relationships" xmlns:p="http://schemas.openxmlformats.org/presentationml/2006/main">
   <p:cSld>
     <p:spTree>
@@ -3040,7 +3399,7 @@
           <a:p>
             <a:fld id="{F7021451-1387-4CA6-816F-3879F97B5CBC}" type="slidenum">
               <a:rPr lang="en-US"/>
-              <a:t>35</a:t>
+              <a:t>39</a:t>
             </a:fld>
             <a:endParaRPr lang="en-US"/>
           </a:p>
@@ -3059,7 +3418,7 @@
 </p:notes>
 </file>
 
-<file path=ppt/notesSlides/notesSlide36.xml><?xml version="1.0" encoding="utf-8"?>
+<file path=ppt/notesSlides/notesSlide4.xml><?xml version="1.0" encoding="utf-8"?>
 <p:notes xmlns:a="http://schemas.openxmlformats.org/drawingml/2006/main" xmlns:r="http://schemas.openxmlformats.org/officeDocument/2006/relationships" xmlns:p="http://schemas.openxmlformats.org/presentationml/2006/main">
   <p:cSld>
     <p:spTree>
@@ -3128,7 +3487,7 @@
           <a:p>
             <a:fld id="{F7021451-1387-4CA6-816F-3879F97B5CBC}" type="slidenum">
               <a:rPr lang="en-US"/>
-              <a:t>36</a:t>
+              <a:t>4</a:t>
             </a:fld>
             <a:endParaRPr lang="en-US"/>
           </a:p>
@@ -3147,7 +3506,7 @@
 </p:notes>
 </file>
 
-<file path=ppt/notesSlides/notesSlide37.xml><?xml version="1.0" encoding="utf-8"?>
+<file path=ppt/notesSlides/notesSlide40.xml><?xml version="1.0" encoding="utf-8"?>
 <p:notes xmlns:a="http://schemas.openxmlformats.org/drawingml/2006/main" xmlns:r="http://schemas.openxmlformats.org/officeDocument/2006/relationships" xmlns:p="http://schemas.openxmlformats.org/presentationml/2006/main">
   <p:cSld>
     <p:spTree>
@@ -3216,7 +3575,7 @@
           <a:p>
             <a:fld id="{F7021451-1387-4CA6-816F-3879F97B5CBC}" type="slidenum">
               <a:rPr lang="en-US"/>
-              <a:t>37</a:t>
+              <a:t>40</a:t>
             </a:fld>
             <a:endParaRPr lang="en-US"/>
           </a:p>
@@ -3235,7 +3594,7 @@
 </p:notes>
 </file>
 
-<file path=ppt/notesSlides/notesSlide38.xml><?xml version="1.0" encoding="utf-8"?>
+<file path=ppt/notesSlides/notesSlide41.xml><?xml version="1.0" encoding="utf-8"?>
 <p:notes xmlns:a="http://schemas.openxmlformats.org/drawingml/2006/main" xmlns:r="http://schemas.openxmlformats.org/officeDocument/2006/relationships" xmlns:p="http://schemas.openxmlformats.org/presentationml/2006/main">
   <p:cSld>
     <p:spTree>
@@ -3304,7 +3663,7 @@
           <a:p>
             <a:fld id="{F7021451-1387-4CA6-816F-3879F97B5CBC}" type="slidenum">
               <a:rPr lang="en-US"/>
-              <a:t>38</a:t>
+              <a:t>41</a:t>
             </a:fld>
             <a:endParaRPr lang="en-US"/>
           </a:p>
@@ -3323,271 +3682,7 @@
 </p:notes>
 </file>
 
-<file path=ppt/notesSlides/notesSlide39.xml><?xml version="1.0" encoding="utf-8"?>
-<p:notes xmlns:a="http://schemas.openxmlformats.org/drawingml/2006/main" xmlns:r="http://schemas.openxmlformats.org/officeDocument/2006/relationships" xmlns:p="http://schemas.openxmlformats.org/presentationml/2006/main">
-  <p:cSld>
-    <p:spTree>
-      <p:nvGrpSpPr>
-        <p:cNvPr id="1" name=""/>
-        <p:cNvGrpSpPr/>
-        <p:nvPr/>
-      </p:nvGrpSpPr>
-      <p:grpSpPr>
-        <a:xfrm>
-          <a:off x="0" y="0"/>
-          <a:ext cx="0" cy="0"/>
-          <a:chOff x="0" y="0"/>
-          <a:chExt cx="0" cy="0"/>
-        </a:xfrm>
-      </p:grpSpPr>
-      <p:sp>
-        <p:nvSpPr>
-          <p:cNvPr id="2" name="Slide Image Placeholder 1"/>
-          <p:cNvSpPr>
-            <a:spLocks noGrp="1" noRot="1" noChangeAspect="1"/>
-          </p:cNvSpPr>
-          <p:nvPr>
-            <p:ph type="sldImg"/>
-          </p:nvPr>
-        </p:nvSpPr>
-        <p:spPr/>
-      </p:sp>
-      <p:sp>
-        <p:nvSpPr>
-          <p:cNvPr id="3" name="Notes Placeholder 2"/>
-          <p:cNvSpPr>
-            <a:spLocks noGrp="1"/>
-          </p:cNvSpPr>
-          <p:nvPr>
-            <p:ph type="body" idx="1"/>
-          </p:nvPr>
-        </p:nvSpPr>
-        <p:spPr/>
-        <p:txBody>
-          <a:bodyPr/>
-          <a:lstStyle/>
-          <a:p>
-            <a:r>
-              <a:rPr lang="en-US" dirty="0"/>
-              <a:t/>
-            </a:r>
-            <a:endParaRPr lang="en-US" dirty="0"/>
-          </a:p>
-        </p:txBody>
-      </p:sp>
-      <p:sp>
-        <p:nvSpPr>
-          <p:cNvPr id="4" name="Slide Number Placeholder 3"/>
-          <p:cNvSpPr>
-            <a:spLocks noGrp="1"/>
-          </p:cNvSpPr>
-          <p:nvPr>
-            <p:ph type="sldNum" sz="quarter" idx="10"/>
-          </p:nvPr>
-        </p:nvSpPr>
-        <p:spPr/>
-        <p:txBody>
-          <a:bodyPr/>
-          <a:lstStyle/>
-          <a:p>
-            <a:fld id="{F7021451-1387-4CA6-816F-3879F97B5CBC}" type="slidenum">
-              <a:rPr lang="en-US"/>
-              <a:t>39</a:t>
-            </a:fld>
-            <a:endParaRPr lang="en-US"/>
-          </a:p>
-        </p:txBody>
-      </p:sp>
-    </p:spTree>
-    <p:extLst>
-      <p:ext uri="{BB962C8B-B14F-4D97-AF65-F5344CB8AC3E}">
-        <p14:creationId xmlns:p14="http://schemas.microsoft.com/office/powerpoint/2010/main" val="1024086991"/>
-      </p:ext>
-    </p:extLst>
-  </p:cSld>
-  <p:clrMapOvr>
-    <a:masterClrMapping/>
-  </p:clrMapOvr>
-</p:notes>
-</file>
-
-<file path=ppt/notesSlides/notesSlide4.xml><?xml version="1.0" encoding="utf-8"?>
-<p:notes xmlns:a="http://schemas.openxmlformats.org/drawingml/2006/main" xmlns:r="http://schemas.openxmlformats.org/officeDocument/2006/relationships" xmlns:p="http://schemas.openxmlformats.org/presentationml/2006/main">
-  <p:cSld>
-    <p:spTree>
-      <p:nvGrpSpPr>
-        <p:cNvPr id="1" name=""/>
-        <p:cNvGrpSpPr/>
-        <p:nvPr/>
-      </p:nvGrpSpPr>
-      <p:grpSpPr>
-        <a:xfrm>
-          <a:off x="0" y="0"/>
-          <a:ext cx="0" cy="0"/>
-          <a:chOff x="0" y="0"/>
-          <a:chExt cx="0" cy="0"/>
-        </a:xfrm>
-      </p:grpSpPr>
-      <p:sp>
-        <p:nvSpPr>
-          <p:cNvPr id="2" name="Slide Image Placeholder 1"/>
-          <p:cNvSpPr>
-            <a:spLocks noGrp="1" noRot="1" noChangeAspect="1"/>
-          </p:cNvSpPr>
-          <p:nvPr>
-            <p:ph type="sldImg"/>
-          </p:nvPr>
-        </p:nvSpPr>
-        <p:spPr/>
-      </p:sp>
-      <p:sp>
-        <p:nvSpPr>
-          <p:cNvPr id="3" name="Notes Placeholder 2"/>
-          <p:cNvSpPr>
-            <a:spLocks noGrp="1"/>
-          </p:cNvSpPr>
-          <p:nvPr>
-            <p:ph type="body" idx="1"/>
-          </p:nvPr>
-        </p:nvSpPr>
-        <p:spPr/>
-        <p:txBody>
-          <a:bodyPr/>
-          <a:lstStyle/>
-          <a:p>
-            <a:r>
-              <a:rPr lang="en-US" dirty="0"/>
-              <a:t/>
-            </a:r>
-            <a:endParaRPr lang="en-US" dirty="0"/>
-          </a:p>
-        </p:txBody>
-      </p:sp>
-      <p:sp>
-        <p:nvSpPr>
-          <p:cNvPr id="4" name="Slide Number Placeholder 3"/>
-          <p:cNvSpPr>
-            <a:spLocks noGrp="1"/>
-          </p:cNvSpPr>
-          <p:nvPr>
-            <p:ph type="sldNum" sz="quarter" idx="10"/>
-          </p:nvPr>
-        </p:nvSpPr>
-        <p:spPr/>
-        <p:txBody>
-          <a:bodyPr/>
-          <a:lstStyle/>
-          <a:p>
-            <a:fld id="{F7021451-1387-4CA6-816F-3879F97B5CBC}" type="slidenum">
-              <a:rPr lang="en-US"/>
-              <a:t>4</a:t>
-            </a:fld>
-            <a:endParaRPr lang="en-US"/>
-          </a:p>
-        </p:txBody>
-      </p:sp>
-    </p:spTree>
-    <p:extLst>
-      <p:ext uri="{BB962C8B-B14F-4D97-AF65-F5344CB8AC3E}">
-        <p14:creationId xmlns:p14="http://schemas.microsoft.com/office/powerpoint/2010/main" val="1024086991"/>
-      </p:ext>
-    </p:extLst>
-  </p:cSld>
-  <p:clrMapOvr>
-    <a:masterClrMapping/>
-  </p:clrMapOvr>
-</p:notes>
-</file>
-
-<file path=ppt/notesSlides/notesSlide40.xml><?xml version="1.0" encoding="utf-8"?>
-<p:notes xmlns:a="http://schemas.openxmlformats.org/drawingml/2006/main" xmlns:r="http://schemas.openxmlformats.org/officeDocument/2006/relationships" xmlns:p="http://schemas.openxmlformats.org/presentationml/2006/main">
-  <p:cSld>
-    <p:spTree>
-      <p:nvGrpSpPr>
-        <p:cNvPr id="1" name=""/>
-        <p:cNvGrpSpPr/>
-        <p:nvPr/>
-      </p:nvGrpSpPr>
-      <p:grpSpPr>
-        <a:xfrm>
-          <a:off x="0" y="0"/>
-          <a:ext cx="0" cy="0"/>
-          <a:chOff x="0" y="0"/>
-          <a:chExt cx="0" cy="0"/>
-        </a:xfrm>
-      </p:grpSpPr>
-      <p:sp>
-        <p:nvSpPr>
-          <p:cNvPr id="2" name="Slide Image Placeholder 1"/>
-          <p:cNvSpPr>
-            <a:spLocks noGrp="1" noRot="1" noChangeAspect="1"/>
-          </p:cNvSpPr>
-          <p:nvPr>
-            <p:ph type="sldImg"/>
-          </p:nvPr>
-        </p:nvSpPr>
-        <p:spPr/>
-      </p:sp>
-      <p:sp>
-        <p:nvSpPr>
-          <p:cNvPr id="3" name="Notes Placeholder 2"/>
-          <p:cNvSpPr>
-            <a:spLocks noGrp="1"/>
-          </p:cNvSpPr>
-          <p:nvPr>
-            <p:ph type="body" idx="1"/>
-          </p:nvPr>
-        </p:nvSpPr>
-        <p:spPr/>
-        <p:txBody>
-          <a:bodyPr/>
-          <a:lstStyle/>
-          <a:p>
-            <a:r>
-              <a:rPr lang="en-US" dirty="0"/>
-              <a:t/>
-            </a:r>
-            <a:endParaRPr lang="en-US" dirty="0"/>
-          </a:p>
-        </p:txBody>
-      </p:sp>
-      <p:sp>
-        <p:nvSpPr>
-          <p:cNvPr id="4" name="Slide Number Placeholder 3"/>
-          <p:cNvSpPr>
-            <a:spLocks noGrp="1"/>
-          </p:cNvSpPr>
-          <p:nvPr>
-            <p:ph type="sldNum" sz="quarter" idx="10"/>
-          </p:nvPr>
-        </p:nvSpPr>
-        <p:spPr/>
-        <p:txBody>
-          <a:bodyPr/>
-          <a:lstStyle/>
-          <a:p>
-            <a:fld id="{F7021451-1387-4CA6-816F-3879F97B5CBC}" type="slidenum">
-              <a:rPr lang="en-US"/>
-              <a:t>40</a:t>
-            </a:fld>
-            <a:endParaRPr lang="en-US"/>
-          </a:p>
-        </p:txBody>
-      </p:sp>
-    </p:spTree>
-    <p:extLst>
-      <p:ext uri="{BB962C8B-B14F-4D97-AF65-F5344CB8AC3E}">
-        <p14:creationId xmlns:p14="http://schemas.microsoft.com/office/powerpoint/2010/main" val="1024086991"/>
-      </p:ext>
-    </p:extLst>
-  </p:cSld>
-  <p:clrMapOvr>
-    <a:masterClrMapping/>
-  </p:clrMapOvr>
-</p:notes>
-</file>
-
-<file path=ppt/notesSlides/notesSlide41.xml><?xml version="1.0" encoding="utf-8"?>
+<file path=ppt/notesSlides/notesSlide42.xml><?xml version="1.0" encoding="utf-8"?>
 <p:notes xmlns:a="http://schemas.openxmlformats.org/drawingml/2006/main" xmlns:r="http://schemas.openxmlformats.org/officeDocument/2006/relationships" xmlns:p="http://schemas.openxmlformats.org/presentationml/2006/main">
   <p:cSld>
     <p:spTree>
@@ -3657,7 +3752,7 @@
           <a:p>
             <a:fld id="{F7021451-1387-4CA6-816F-3879F97B5CBC}" type="slidenum">
               <a:rPr lang="en-US"/>
-              <a:t>41</a:t>
+              <a:t>42</a:t>
             </a:fld>
             <a:endParaRPr lang="en-US"/>
           </a:p>
@@ -3676,7 +3771,7 @@
 </p:notes>
 </file>
 
-<file path=ppt/notesSlides/notesSlide42.xml><?xml version="1.0" encoding="utf-8"?>
+<file path=ppt/notesSlides/notesSlide43.xml><?xml version="1.0" encoding="utf-8"?>
 <p:notes xmlns:a="http://schemas.openxmlformats.org/drawingml/2006/main" xmlns:r="http://schemas.openxmlformats.org/officeDocument/2006/relationships" xmlns:p="http://schemas.openxmlformats.org/presentationml/2006/main">
   <p:cSld>
     <p:spTree>
@@ -3745,7 +3840,7 @@
           <a:p>
             <a:fld id="{F7021451-1387-4CA6-816F-3879F97B5CBC}" type="slidenum">
               <a:rPr lang="en-US"/>
-              <a:t>42</a:t>
+              <a:t>43</a:t>
             </a:fld>
             <a:endParaRPr lang="en-US"/>
           </a:p>
@@ -3764,7 +3859,7 @@
 </p:notes>
 </file>
 
-<file path=ppt/notesSlides/notesSlide43.xml><?xml version="1.0" encoding="utf-8"?>
+<file path=ppt/notesSlides/notesSlide44.xml><?xml version="1.0" encoding="utf-8"?>
 <p:notes xmlns:a="http://schemas.openxmlformats.org/drawingml/2006/main" xmlns:r="http://schemas.openxmlformats.org/officeDocument/2006/relationships" xmlns:p="http://schemas.openxmlformats.org/presentationml/2006/main">
   <p:cSld>
     <p:spTree>
@@ -3833,7 +3928,7 @@
           <a:p>
             <a:fld id="{F7021451-1387-4CA6-816F-3879F97B5CBC}" type="slidenum">
               <a:rPr lang="en-US"/>
-              <a:t>43</a:t>
+              <a:t>44</a:t>
             </a:fld>
             <a:endParaRPr lang="en-US"/>
           </a:p>
@@ -3852,7 +3947,7 @@
 </p:notes>
 </file>
 
-<file path=ppt/notesSlides/notesSlide44.xml><?xml version="1.0" encoding="utf-8"?>
+<file path=ppt/notesSlides/notesSlide45.xml><?xml version="1.0" encoding="utf-8"?>
 <p:notes xmlns:a="http://schemas.openxmlformats.org/drawingml/2006/main" xmlns:r="http://schemas.openxmlformats.org/officeDocument/2006/relationships" xmlns:p="http://schemas.openxmlformats.org/presentationml/2006/main">
   <p:cSld>
     <p:spTree>
@@ -3921,7 +4016,7 @@
           <a:p>
             <a:fld id="{F7021451-1387-4CA6-816F-3879F97B5CBC}" type="slidenum">
               <a:rPr lang="en-US"/>
-              <a:t>44</a:t>
+              <a:t>45</a:t>
             </a:fld>
             <a:endParaRPr lang="en-US"/>
           </a:p>
@@ -6173,6 +6268,45 @@
 <file path=ppt/slides/slide44.xml><?xml version="1.0" encoding="utf-8"?>
 <p:sld xmlns:a="http://schemas.openxmlformats.org/drawingml/2006/main" xmlns:r="http://schemas.openxmlformats.org/officeDocument/2006/relationships" xmlns:p="http://schemas.openxmlformats.org/presentationml/2006/main">
   <p:cSld name="Slide 44">
+    <p:bg>
+      <p:bgPr>
+        <a:blipFill dpi="0" rotWithShape="1">
+          <a:blip r:embed="rId1">
+            <a:lum/>
+          </a:blip>
+          <a:srcRect/>
+          <a:stretch>
+            <a:fillRect/>
+          </a:stretch>
+        </a:blipFill>
+        <a:effectLst/>
+      </p:bgPr>
+    </p:bg>
+    <p:spTree>
+      <p:nvGrpSpPr>
+        <p:cNvPr id="1" name=""/>
+        <p:cNvGrpSpPr/>
+        <p:nvPr/>
+      </p:nvGrpSpPr>
+      <p:grpSpPr>
+        <a:xfrm>
+          <a:off x="0" y="0"/>
+          <a:ext cx="0" cy="0"/>
+          <a:chOff x="0" y="0"/>
+          <a:chExt cx="0" cy="0"/>
+        </a:xfrm>
+      </p:grpSpPr>
+    </p:spTree>
+  </p:cSld>
+  <p:clrMapOvr>
+    <a:masterClrMapping/>
+  </p:clrMapOvr>
+</p:sld>
+</file>
+
+<file path=ppt/slides/slide45.xml><?xml version="1.0" encoding="utf-8"?>
+<p:sld xmlns:a="http://schemas.openxmlformats.org/drawingml/2006/main" xmlns:r="http://schemas.openxmlformats.org/officeDocument/2006/relationships" xmlns:p="http://schemas.openxmlformats.org/presentationml/2006/main">
+  <p:cSld name="Slide 45">
     <p:bg>
       <p:bgPr>
         <a:blipFill dpi="0" rotWithShape="1">

</xml_diff>

<commit_message>
L02: republish with the real-tokenizer slide and YouTube resources
32 slides to 34. Token IDs computed with tiktoken over o200k_base, not
transcribed. Video titles fetched, not recalled.

https://claude.ai/code/session_01Nac3M9CHSMSmoRnkHhPjB1
</commit_message>
<xml_diff>
--- a/lectures/L02/slides.pptx
+++ b/lectures/L02/slides.pptx
@@ -50,9 +50,11 @@
     <p:sldId id="298" r:id="rId44"/>
     <p:sldId id="299" r:id="rId45"/>
     <p:sldId id="300" r:id="rId46"/>
+    <p:sldId id="301" r:id="rId47"/>
+    <p:sldId id="302" r:id="rId48"/>
   </p:sldIdLst>
   <p:notesMasterIdLst>
-    <p:notesMasterId r:id="rId47"/>
+    <p:notesMasterId r:id="rId49"/>
   </p:notesMasterIdLst>
   <p:sldSz cx="9334500" cy="5248275"/>
   <p:notesSz cx="5248275" cy="9334500"/>
@@ -723,7 +725,7 @@
           <a:p>
             <a:r>
               <a:rPr lang="en-US" dirty="0"/>
-              <a:t>Rose accent on the surprising one — quality degradation.</a:t>
+              <a:t/>
             </a:r>
             <a:endParaRPr lang="en-US" dirty="0"/>
           </a:p>
@@ -766,6 +768,94 @@
 </file>
 
 <file path=ppt/notesSlides/notesSlide12.xml><?xml version="1.0" encoding="utf-8"?>
+<p:notes xmlns:a="http://schemas.openxmlformats.org/drawingml/2006/main" xmlns:r="http://schemas.openxmlformats.org/officeDocument/2006/relationships" xmlns:p="http://schemas.openxmlformats.org/presentationml/2006/main">
+  <p:cSld>
+    <p:spTree>
+      <p:nvGrpSpPr>
+        <p:cNvPr id="1" name=""/>
+        <p:cNvGrpSpPr/>
+        <p:nvPr/>
+      </p:nvGrpSpPr>
+      <p:grpSpPr>
+        <a:xfrm>
+          <a:off x="0" y="0"/>
+          <a:ext cx="0" cy="0"/>
+          <a:chOff x="0" y="0"/>
+          <a:chExt cx="0" cy="0"/>
+        </a:xfrm>
+      </p:grpSpPr>
+      <p:sp>
+        <p:nvSpPr>
+          <p:cNvPr id="2" name="Slide Image Placeholder 1"/>
+          <p:cNvSpPr>
+            <a:spLocks noGrp="1" noRot="1" noChangeAspect="1"/>
+          </p:cNvSpPr>
+          <p:nvPr>
+            <p:ph type="sldImg"/>
+          </p:nvPr>
+        </p:nvSpPr>
+        <p:spPr/>
+      </p:sp>
+      <p:sp>
+        <p:nvSpPr>
+          <p:cNvPr id="3" name="Notes Placeholder 2"/>
+          <p:cNvSpPr>
+            <a:spLocks noGrp="1"/>
+          </p:cNvSpPr>
+          <p:nvPr>
+            <p:ph type="body" idx="1"/>
+          </p:nvPr>
+        </p:nvSpPr>
+        <p:spPr/>
+        <p:txBody>
+          <a:bodyPr/>
+          <a:lstStyle/>
+          <a:p>
+            <a:r>
+              <a:rPr lang="en-US" dirty="0"/>
+              <a:t>Rose accent on the surprising one — quality degradation.</a:t>
+            </a:r>
+            <a:endParaRPr lang="en-US" dirty="0"/>
+          </a:p>
+        </p:txBody>
+      </p:sp>
+      <p:sp>
+        <p:nvSpPr>
+          <p:cNvPr id="4" name="Slide Number Placeholder 3"/>
+          <p:cNvSpPr>
+            <a:spLocks noGrp="1"/>
+          </p:cNvSpPr>
+          <p:nvPr>
+            <p:ph type="sldNum" sz="quarter" idx="10"/>
+          </p:nvPr>
+        </p:nvSpPr>
+        <p:spPr/>
+        <p:txBody>
+          <a:bodyPr/>
+          <a:lstStyle/>
+          <a:p>
+            <a:fld id="{F7021451-1387-4CA6-816F-3879F97B5CBC}" type="slidenum">
+              <a:rPr lang="en-US"/>
+              <a:t>12</a:t>
+            </a:fld>
+            <a:endParaRPr lang="en-US"/>
+          </a:p>
+        </p:txBody>
+      </p:sp>
+    </p:spTree>
+    <p:extLst>
+      <p:ext uri="{BB962C8B-B14F-4D97-AF65-F5344CB8AC3E}">
+        <p14:creationId xmlns:p14="http://schemas.microsoft.com/office/powerpoint/2010/main" val="1024086991"/>
+      </p:ext>
+    </p:extLst>
+  </p:cSld>
+  <p:clrMapOvr>
+    <a:masterClrMapping/>
+  </p:clrMapOvr>
+</p:notes>
+</file>
+
+<file path=ppt/notesSlides/notesSlide13.xml><?xml version="1.0" encoding="utf-8"?>
 <p:notes xmlns:a="http://schemas.openxmlformats.org/drawingml/2006/main" xmlns:r="http://schemas.openxmlformats.org/officeDocument/2006/relationships" xmlns:p="http://schemas.openxmlformats.org/presentationml/2006/main">
   <p:cSld>
     <p:spTree>
@@ -838,7 +928,7 @@
           <a:p>
             <a:fld id="{F7021451-1387-4CA6-816F-3879F97B5CBC}" type="slidenum">
               <a:rPr lang="en-US"/>
-              <a:t>12</a:t>
+              <a:t>13</a:t>
             </a:fld>
             <a:endParaRPr lang="en-US"/>
           </a:p>
@@ -857,7 +947,7 @@
 </p:notes>
 </file>
 
-<file path=ppt/notesSlides/notesSlide13.xml><?xml version="1.0" encoding="utf-8"?>
+<file path=ppt/notesSlides/notesSlide14.xml><?xml version="1.0" encoding="utf-8"?>
 <p:notes xmlns:a="http://schemas.openxmlformats.org/drawingml/2006/main" xmlns:r="http://schemas.openxmlformats.org/officeDocument/2006/relationships" xmlns:p="http://schemas.openxmlformats.org/presentationml/2006/main">
   <p:cSld>
     <p:spTree>
@@ -927,7 +1017,7 @@
           <a:p>
             <a:fld id="{F7021451-1387-4CA6-816F-3879F97B5CBC}" type="slidenum">
               <a:rPr lang="en-US"/>
-              <a:t>13</a:t>
+              <a:t>14</a:t>
             </a:fld>
             <a:endParaRPr lang="en-US"/>
           </a:p>
@@ -946,7 +1036,7 @@
 </p:notes>
 </file>
 
-<file path=ppt/notesSlides/notesSlide14.xml><?xml version="1.0" encoding="utf-8"?>
+<file path=ppt/notesSlides/notesSlide15.xml><?xml version="1.0" encoding="utf-8"?>
 <p:notes xmlns:a="http://schemas.openxmlformats.org/drawingml/2006/main" xmlns:r="http://schemas.openxmlformats.org/officeDocument/2006/relationships" xmlns:p="http://schemas.openxmlformats.org/presentationml/2006/main">
   <p:cSld>
     <p:spTree>
@@ -1015,7 +1105,7 @@
           <a:p>
             <a:fld id="{F7021451-1387-4CA6-816F-3879F97B5CBC}" type="slidenum">
               <a:rPr lang="en-US"/>
-              <a:t>14</a:t>
+              <a:t>15</a:t>
             </a:fld>
             <a:endParaRPr lang="en-US"/>
           </a:p>
@@ -1034,7 +1124,7 @@
 </p:notes>
 </file>
 
-<file path=ppt/notesSlides/notesSlide15.xml><?xml version="1.0" encoding="utf-8"?>
+<file path=ppt/notesSlides/notesSlide16.xml><?xml version="1.0" encoding="utf-8"?>
 <p:notes xmlns:a="http://schemas.openxmlformats.org/drawingml/2006/main" xmlns:r="http://schemas.openxmlformats.org/officeDocument/2006/relationships" xmlns:p="http://schemas.openxmlformats.org/presentationml/2006/main">
   <p:cSld>
     <p:spTree>
@@ -1103,7 +1193,7 @@
           <a:p>
             <a:fld id="{F7021451-1387-4CA6-816F-3879F97B5CBC}" type="slidenum">
               <a:rPr lang="en-US"/>
-              <a:t>15</a:t>
+              <a:t>16</a:t>
             </a:fld>
             <a:endParaRPr lang="en-US"/>
           </a:p>
@@ -1122,7 +1212,7 @@
 </p:notes>
 </file>
 
-<file path=ppt/notesSlides/notesSlide16.xml><?xml version="1.0" encoding="utf-8"?>
+<file path=ppt/notesSlides/notesSlide17.xml><?xml version="1.0" encoding="utf-8"?>
 <p:notes xmlns:a="http://schemas.openxmlformats.org/drawingml/2006/main" xmlns:r="http://schemas.openxmlformats.org/officeDocument/2006/relationships" xmlns:p="http://schemas.openxmlformats.org/presentationml/2006/main">
   <p:cSld>
     <p:spTree>
@@ -1196,7 +1286,7 @@
           <a:p>
             <a:fld id="{F7021451-1387-4CA6-816F-3879F97B5CBC}" type="slidenum">
               <a:rPr lang="en-US"/>
-              <a:t>16</a:t>
+              <a:t>17</a:t>
             </a:fld>
             <a:endParaRPr lang="en-US"/>
           </a:p>
@@ -1215,7 +1305,7 @@
 </p:notes>
 </file>
 
-<file path=ppt/notesSlides/notesSlide17.xml><?xml version="1.0" encoding="utf-8"?>
+<file path=ppt/notesSlides/notesSlide18.xml><?xml version="1.0" encoding="utf-8"?>
 <p:notes xmlns:a="http://schemas.openxmlformats.org/drawingml/2006/main" xmlns:r="http://schemas.openxmlformats.org/officeDocument/2006/relationships" xmlns:p="http://schemas.openxmlformats.org/presentationml/2006/main">
   <p:cSld>
     <p:spTree>
@@ -1284,7 +1374,7 @@
           <a:p>
             <a:fld id="{F7021451-1387-4CA6-816F-3879F97B5CBC}" type="slidenum">
               <a:rPr lang="en-US"/>
-              <a:t>17</a:t>
+              <a:t>18</a:t>
             </a:fld>
             <a:endParaRPr lang="en-US"/>
           </a:p>
@@ -1303,7 +1393,7 @@
 </p:notes>
 </file>
 
-<file path=ppt/notesSlides/notesSlide18.xml><?xml version="1.0" encoding="utf-8"?>
+<file path=ppt/notesSlides/notesSlide19.xml><?xml version="1.0" encoding="utf-8"?>
 <p:notes xmlns:a="http://schemas.openxmlformats.org/drawingml/2006/main" xmlns:r="http://schemas.openxmlformats.org/officeDocument/2006/relationships" xmlns:p="http://schemas.openxmlformats.org/presentationml/2006/main">
   <p:cSld>
     <p:spTree>
@@ -1372,7 +1462,7 @@
           <a:p>
             <a:fld id="{F7021451-1387-4CA6-816F-3879F97B5CBC}" type="slidenum">
               <a:rPr lang="en-US"/>
-              <a:t>18</a:t>
+              <a:t>19</a:t>
             </a:fld>
             <a:endParaRPr lang="en-US"/>
           </a:p>
@@ -1391,7 +1481,95 @@
 </p:notes>
 </file>
 
-<file path=ppt/notesSlides/notesSlide19.xml><?xml version="1.0" encoding="utf-8"?>
+<file path=ppt/notesSlides/notesSlide2.xml><?xml version="1.0" encoding="utf-8"?>
+<p:notes xmlns:a="http://schemas.openxmlformats.org/drawingml/2006/main" xmlns:r="http://schemas.openxmlformats.org/officeDocument/2006/relationships" xmlns:p="http://schemas.openxmlformats.org/presentationml/2006/main">
+  <p:cSld>
+    <p:spTree>
+      <p:nvGrpSpPr>
+        <p:cNvPr id="1" name=""/>
+        <p:cNvGrpSpPr/>
+        <p:nvPr/>
+      </p:nvGrpSpPr>
+      <p:grpSpPr>
+        <a:xfrm>
+          <a:off x="0" y="0"/>
+          <a:ext cx="0" cy="0"/>
+          <a:chOff x="0" y="0"/>
+          <a:chExt cx="0" cy="0"/>
+        </a:xfrm>
+      </p:grpSpPr>
+      <p:sp>
+        <p:nvSpPr>
+          <p:cNvPr id="2" name="Slide Image Placeholder 1"/>
+          <p:cNvSpPr>
+            <a:spLocks noGrp="1" noRot="1" noChangeAspect="1"/>
+          </p:cNvSpPr>
+          <p:nvPr>
+            <p:ph type="sldImg"/>
+          </p:nvPr>
+        </p:nvSpPr>
+        <p:spPr/>
+      </p:sp>
+      <p:sp>
+        <p:nvSpPr>
+          <p:cNvPr id="3" name="Notes Placeholder 2"/>
+          <p:cNvSpPr>
+            <a:spLocks noGrp="1"/>
+          </p:cNvSpPr>
+          <p:nvPr>
+            <p:ph type="body" idx="1"/>
+          </p:nvPr>
+        </p:nvSpPr>
+        <p:spPr/>
+        <p:txBody>
+          <a:bodyPr/>
+          <a:lstStyle/>
+          <a:p>
+            <a:r>
+              <a:rPr lang="en-US" dirty="0"/>
+              <a:t>The opener: why bother with theory. When it doesn't work, mental models win.</a:t>
+            </a:r>
+            <a:endParaRPr lang="en-US" dirty="0"/>
+          </a:p>
+        </p:txBody>
+      </p:sp>
+      <p:sp>
+        <p:nvSpPr>
+          <p:cNvPr id="4" name="Slide Number Placeholder 3"/>
+          <p:cNvSpPr>
+            <a:spLocks noGrp="1"/>
+          </p:cNvSpPr>
+          <p:nvPr>
+            <p:ph type="sldNum" sz="quarter" idx="10"/>
+          </p:nvPr>
+        </p:nvSpPr>
+        <p:spPr/>
+        <p:txBody>
+          <a:bodyPr/>
+          <a:lstStyle/>
+          <a:p>
+            <a:fld id="{F7021451-1387-4CA6-816F-3879F97B5CBC}" type="slidenum">
+              <a:rPr lang="en-US"/>
+              <a:t>2</a:t>
+            </a:fld>
+            <a:endParaRPr lang="en-US"/>
+          </a:p>
+        </p:txBody>
+      </p:sp>
+    </p:spTree>
+    <p:extLst>
+      <p:ext uri="{BB962C8B-B14F-4D97-AF65-F5344CB8AC3E}">
+        <p14:creationId xmlns:p14="http://schemas.microsoft.com/office/powerpoint/2010/main" val="1024086991"/>
+      </p:ext>
+    </p:extLst>
+  </p:cSld>
+  <p:clrMapOvr>
+    <a:masterClrMapping/>
+  </p:clrMapOvr>
+</p:notes>
+</file>
+
+<file path=ppt/notesSlides/notesSlide20.xml><?xml version="1.0" encoding="utf-8"?>
 <p:notes xmlns:a="http://schemas.openxmlformats.org/drawingml/2006/main" xmlns:r="http://schemas.openxmlformats.org/officeDocument/2006/relationships" xmlns:p="http://schemas.openxmlformats.org/presentationml/2006/main">
   <p:cSld>
     <p:spTree>
@@ -1460,7 +1638,7 @@
           <a:p>
             <a:fld id="{F7021451-1387-4CA6-816F-3879F97B5CBC}" type="slidenum">
               <a:rPr lang="en-US"/>
-              <a:t>19</a:t>
+              <a:t>20</a:t>
             </a:fld>
             <a:endParaRPr lang="en-US"/>
           </a:p>
@@ -1479,7 +1657,7 @@
 </p:notes>
 </file>
 
-<file path=ppt/notesSlides/notesSlide2.xml><?xml version="1.0" encoding="utf-8"?>
+<file path=ppt/notesSlides/notesSlide21.xml><?xml version="1.0" encoding="utf-8"?>
 <p:notes xmlns:a="http://schemas.openxmlformats.org/drawingml/2006/main" xmlns:r="http://schemas.openxmlformats.org/officeDocument/2006/relationships" xmlns:p="http://schemas.openxmlformats.org/presentationml/2006/main">
   <p:cSld>
     <p:spTree>
@@ -1525,7 +1703,7 @@
           <a:p>
             <a:r>
               <a:rPr lang="en-US" dirty="0"/>
-              <a:t>The opener: why bother with theory. When it doesn't work, mental models win.</a:t>
+              <a:t>"Hallucination" sounds like a mistake. It's not a mistake — it's the design.</a:t>
             </a:r>
             <a:endParaRPr lang="en-US" dirty="0"/>
           </a:p>
@@ -1548,7 +1726,7 @@
           <a:p>
             <a:fld id="{F7021451-1387-4CA6-816F-3879F97B5CBC}" type="slidenum">
               <a:rPr lang="en-US"/>
-              <a:t>2</a:t>
+              <a:t>21</a:t>
             </a:fld>
             <a:endParaRPr lang="en-US"/>
           </a:p>
@@ -1567,7 +1745,7 @@
 </p:notes>
 </file>
 
-<file path=ppt/notesSlides/notesSlide20.xml><?xml version="1.0" encoding="utf-8"?>
+<file path=ppt/notesSlides/notesSlide22.xml><?xml version="1.0" encoding="utf-8"?>
 <p:notes xmlns:a="http://schemas.openxmlformats.org/drawingml/2006/main" xmlns:r="http://schemas.openxmlformats.org/officeDocument/2006/relationships" xmlns:p="http://schemas.openxmlformats.org/presentationml/2006/main">
   <p:cSld>
     <p:spTree>
@@ -1636,7 +1814,7 @@
           <a:p>
             <a:fld id="{F7021451-1387-4CA6-816F-3879F97B5CBC}" type="slidenum">
               <a:rPr lang="en-US"/>
-              <a:t>20</a:t>
+              <a:t>22</a:t>
             </a:fld>
             <a:endParaRPr lang="en-US"/>
           </a:p>
@@ -1655,7 +1833,7 @@
 </p:notes>
 </file>
 
-<file path=ppt/notesSlides/notesSlide21.xml><?xml version="1.0" encoding="utf-8"?>
+<file path=ppt/notesSlides/notesSlide23.xml><?xml version="1.0" encoding="utf-8"?>
 <p:notes xmlns:a="http://schemas.openxmlformats.org/drawingml/2006/main" xmlns:r="http://schemas.openxmlformats.org/officeDocument/2006/relationships" xmlns:p="http://schemas.openxmlformats.org/presentationml/2006/main">
   <p:cSld>
     <p:spTree>
@@ -1724,7 +1902,7 @@
           <a:p>
             <a:fld id="{F7021451-1387-4CA6-816F-3879F97B5CBC}" type="slidenum">
               <a:rPr lang="en-US"/>
-              <a:t>21</a:t>
+              <a:t>23</a:t>
             </a:fld>
             <a:endParaRPr lang="en-US"/>
           </a:p>
@@ -1743,7 +1921,7 @@
 </p:notes>
 </file>
 
-<file path=ppt/notesSlides/notesSlide22.xml><?xml version="1.0" encoding="utf-8"?>
+<file path=ppt/notesSlides/notesSlide24.xml><?xml version="1.0" encoding="utf-8"?>
 <p:notes xmlns:a="http://schemas.openxmlformats.org/drawingml/2006/main" xmlns:r="http://schemas.openxmlformats.org/officeDocument/2006/relationships" xmlns:p="http://schemas.openxmlformats.org/presentationml/2006/main">
   <p:cSld>
     <p:spTree>
@@ -1812,7 +1990,7 @@
           <a:p>
             <a:fld id="{F7021451-1387-4CA6-816F-3879F97B5CBC}" type="slidenum">
               <a:rPr lang="en-US"/>
-              <a:t>22</a:t>
+              <a:t>24</a:t>
             </a:fld>
             <a:endParaRPr lang="en-US"/>
           </a:p>
@@ -1831,7 +2009,7 @@
 </p:notes>
 </file>
 
-<file path=ppt/notesSlides/notesSlide23.xml><?xml version="1.0" encoding="utf-8"?>
+<file path=ppt/notesSlides/notesSlide25.xml><?xml version="1.0" encoding="utf-8"?>
 <p:notes xmlns:a="http://schemas.openxmlformats.org/drawingml/2006/main" xmlns:r="http://schemas.openxmlformats.org/officeDocument/2006/relationships" xmlns:p="http://schemas.openxmlformats.org/presentationml/2006/main">
   <p:cSld>
     <p:spTree>
@@ -1877,7 +2055,7 @@
           <a:p>
             <a:r>
               <a:rPr lang="en-US" dirty="0"/>
-              <a:t>"Hallucination" sounds like a mistake. It's not a mistake — it's the design.</a:t>
+              <a:t>Not "made up" — wrong real library for the wrong real project.</a:t>
             </a:r>
             <a:endParaRPr lang="en-US" dirty="0"/>
           </a:p>
@@ -1900,7 +2078,7 @@
           <a:p>
             <a:fld id="{F7021451-1387-4CA6-816F-3879F97B5CBC}" type="slidenum">
               <a:rPr lang="en-US"/>
-              <a:t>23</a:t>
+              <a:t>25</a:t>
             </a:fld>
             <a:endParaRPr lang="en-US"/>
           </a:p>
@@ -1919,7 +2097,7 @@
 </p:notes>
 </file>
 
-<file path=ppt/notesSlides/notesSlide24.xml><?xml version="1.0" encoding="utf-8"?>
+<file path=ppt/notesSlides/notesSlide26.xml><?xml version="1.0" encoding="utf-8"?>
 <p:notes xmlns:a="http://schemas.openxmlformats.org/drawingml/2006/main" xmlns:r="http://schemas.openxmlformats.org/officeDocument/2006/relationships" xmlns:p="http://schemas.openxmlformats.org/presentationml/2006/main">
   <p:cSld>
     <p:spTree>
@@ -1988,7 +2166,7 @@
           <a:p>
             <a:fld id="{F7021451-1387-4CA6-816F-3879F97B5CBC}" type="slidenum">
               <a:rPr lang="en-US"/>
-              <a:t>24</a:t>
+              <a:t>26</a:t>
             </a:fld>
             <a:endParaRPr lang="en-US"/>
           </a:p>
@@ -2007,7 +2185,7 @@
 </p:notes>
 </file>
 
-<file path=ppt/notesSlides/notesSlide25.xml><?xml version="1.0" encoding="utf-8"?>
+<file path=ppt/notesSlides/notesSlide27.xml><?xml version="1.0" encoding="utf-8"?>
 <p:notes xmlns:a="http://schemas.openxmlformats.org/drawingml/2006/main" xmlns:r="http://schemas.openxmlformats.org/officeDocument/2006/relationships" xmlns:p="http://schemas.openxmlformats.org/presentationml/2006/main">
   <p:cSld>
     <p:spTree>
@@ -2076,7 +2254,7 @@
           <a:p>
             <a:fld id="{F7021451-1387-4CA6-816F-3879F97B5CBC}" type="slidenum">
               <a:rPr lang="en-US"/>
-              <a:t>25</a:t>
+              <a:t>27</a:t>
             </a:fld>
             <a:endParaRPr lang="en-US"/>
           </a:p>
@@ -2095,7 +2273,7 @@
 </p:notes>
 </file>
 
-<file path=ppt/notesSlides/notesSlide26.xml><?xml version="1.0" encoding="utf-8"?>
+<file path=ppt/notesSlides/notesSlide28.xml><?xml version="1.0" encoding="utf-8"?>
 <p:notes xmlns:a="http://schemas.openxmlformats.org/drawingml/2006/main" xmlns:r="http://schemas.openxmlformats.org/officeDocument/2006/relationships" xmlns:p="http://schemas.openxmlformats.org/presentationml/2006/main">
   <p:cSld>
     <p:spTree>
@@ -2164,7 +2342,7 @@
           <a:p>
             <a:fld id="{F7021451-1387-4CA6-816F-3879F97B5CBC}" type="slidenum">
               <a:rPr lang="en-US"/>
-              <a:t>26</a:t>
+              <a:t>28</a:t>
             </a:fld>
             <a:endParaRPr lang="en-US"/>
           </a:p>
@@ -2183,7 +2361,7 @@
 </p:notes>
 </file>
 
-<file path=ppt/notesSlides/notesSlide27.xml><?xml version="1.0" encoding="utf-8"?>
+<file path=ppt/notesSlides/notesSlide29.xml><?xml version="1.0" encoding="utf-8"?>
 <p:notes xmlns:a="http://schemas.openxmlformats.org/drawingml/2006/main" xmlns:r="http://schemas.openxmlformats.org/officeDocument/2006/relationships" xmlns:p="http://schemas.openxmlformats.org/presentationml/2006/main">
   <p:cSld>
     <p:spTree>
@@ -2252,7 +2430,7 @@
           <a:p>
             <a:fld id="{F7021451-1387-4CA6-816F-3879F97B5CBC}" type="slidenum">
               <a:rPr lang="en-US"/>
-              <a:t>27</a:t>
+              <a:t>29</a:t>
             </a:fld>
             <a:endParaRPr lang="en-US"/>
           </a:p>
@@ -2271,7 +2449,7 @@
 </p:notes>
 </file>
 
-<file path=ppt/notesSlides/notesSlide28.xml><?xml version="1.0" encoding="utf-8"?>
+<file path=ppt/notesSlides/notesSlide3.xml><?xml version="1.0" encoding="utf-8"?>
 <p:notes xmlns:a="http://schemas.openxmlformats.org/drawingml/2006/main" xmlns:r="http://schemas.openxmlformats.org/officeDocument/2006/relationships" xmlns:p="http://schemas.openxmlformats.org/presentationml/2006/main">
   <p:cSld>
     <p:spTree>
@@ -2317,7 +2495,7 @@
           <a:p>
             <a:r>
               <a:rPr lang="en-US" dirty="0"/>
-              <a:t>Not "made up" — wrong real library for the wrong real project.</a:t>
+              <a:t/>
             </a:r>
             <a:endParaRPr lang="en-US" dirty="0"/>
           </a:p>
@@ -2340,7 +2518,7 @@
           <a:p>
             <a:fld id="{F7021451-1387-4CA6-816F-3879F97B5CBC}" type="slidenum">
               <a:rPr lang="en-US"/>
-              <a:t>28</a:t>
+              <a:t>3</a:t>
             </a:fld>
             <a:endParaRPr lang="en-US"/>
           </a:p>
@@ -2359,7 +2537,7 @@
 </p:notes>
 </file>
 
-<file path=ppt/notesSlides/notesSlide29.xml><?xml version="1.0" encoding="utf-8"?>
+<file path=ppt/notesSlides/notesSlide30.xml><?xml version="1.0" encoding="utf-8"?>
 <p:notes xmlns:a="http://schemas.openxmlformats.org/drawingml/2006/main" xmlns:r="http://schemas.openxmlformats.org/officeDocument/2006/relationships" xmlns:p="http://schemas.openxmlformats.org/presentationml/2006/main">
   <p:cSld>
     <p:spTree>
@@ -2428,7 +2606,7 @@
           <a:p>
             <a:fld id="{F7021451-1387-4CA6-816F-3879F97B5CBC}" type="slidenum">
               <a:rPr lang="en-US"/>
-              <a:t>29</a:t>
+              <a:t>30</a:t>
             </a:fld>
             <a:endParaRPr lang="en-US"/>
           </a:p>
@@ -2447,7 +2625,95 @@
 </p:notes>
 </file>
 
-<file path=ppt/notesSlides/notesSlide3.xml><?xml version="1.0" encoding="utf-8"?>
+<file path=ppt/notesSlides/notesSlide31.xml><?xml version="1.0" encoding="utf-8"?>
+<p:notes xmlns:a="http://schemas.openxmlformats.org/drawingml/2006/main" xmlns:r="http://schemas.openxmlformats.org/officeDocument/2006/relationships" xmlns:p="http://schemas.openxmlformats.org/presentationml/2006/main">
+  <p:cSld>
+    <p:spTree>
+      <p:nvGrpSpPr>
+        <p:cNvPr id="1" name=""/>
+        <p:cNvGrpSpPr/>
+        <p:nvPr/>
+      </p:nvGrpSpPr>
+      <p:grpSpPr>
+        <a:xfrm>
+          <a:off x="0" y="0"/>
+          <a:ext cx="0" cy="0"/>
+          <a:chOff x="0" y="0"/>
+          <a:chExt cx="0" cy="0"/>
+        </a:xfrm>
+      </p:grpSpPr>
+      <p:sp>
+        <p:nvSpPr>
+          <p:cNvPr id="2" name="Slide Image Placeholder 1"/>
+          <p:cNvSpPr>
+            <a:spLocks noGrp="1" noRot="1" noChangeAspect="1"/>
+          </p:cNvSpPr>
+          <p:nvPr>
+            <p:ph type="sldImg"/>
+          </p:nvPr>
+        </p:nvSpPr>
+        <p:spPr/>
+      </p:sp>
+      <p:sp>
+        <p:nvSpPr>
+          <p:cNvPr id="3" name="Notes Placeholder 2"/>
+          <p:cNvSpPr>
+            <a:spLocks noGrp="1"/>
+          </p:cNvSpPr>
+          <p:nvPr>
+            <p:ph type="body" idx="1"/>
+          </p:nvPr>
+        </p:nvSpPr>
+        <p:spPr/>
+        <p:txBody>
+          <a:bodyPr/>
+          <a:lstStyle/>
+          <a:p>
+            <a:r>
+              <a:rPr lang="en-US" dirty="0"/>
+              <a:t>The deepest reason to manage context: accuracy. Not cost. Not speed.</a:t>
+            </a:r>
+            <a:endParaRPr lang="en-US" dirty="0"/>
+          </a:p>
+        </p:txBody>
+      </p:sp>
+      <p:sp>
+        <p:nvSpPr>
+          <p:cNvPr id="4" name="Slide Number Placeholder 3"/>
+          <p:cNvSpPr>
+            <a:spLocks noGrp="1"/>
+          </p:cNvSpPr>
+          <p:nvPr>
+            <p:ph type="sldNum" sz="quarter" idx="10"/>
+          </p:nvPr>
+        </p:nvSpPr>
+        <p:spPr/>
+        <p:txBody>
+          <a:bodyPr/>
+          <a:lstStyle/>
+          <a:p>
+            <a:fld id="{F7021451-1387-4CA6-816F-3879F97B5CBC}" type="slidenum">
+              <a:rPr lang="en-US"/>
+              <a:t>31</a:t>
+            </a:fld>
+            <a:endParaRPr lang="en-US"/>
+          </a:p>
+        </p:txBody>
+      </p:sp>
+    </p:spTree>
+    <p:extLst>
+      <p:ext uri="{BB962C8B-B14F-4D97-AF65-F5344CB8AC3E}">
+        <p14:creationId xmlns:p14="http://schemas.microsoft.com/office/powerpoint/2010/main" val="1024086991"/>
+      </p:ext>
+    </p:extLst>
+  </p:cSld>
+  <p:clrMapOvr>
+    <a:masterClrMapping/>
+  </p:clrMapOvr>
+</p:notes>
+</file>
+
+<file path=ppt/notesSlides/notesSlide32.xml><?xml version="1.0" encoding="utf-8"?>
 <p:notes xmlns:a="http://schemas.openxmlformats.org/drawingml/2006/main" xmlns:r="http://schemas.openxmlformats.org/officeDocument/2006/relationships" xmlns:p="http://schemas.openxmlformats.org/presentationml/2006/main">
   <p:cSld>
     <p:spTree>
@@ -2516,7 +2782,7 @@
           <a:p>
             <a:fld id="{F7021451-1387-4CA6-816F-3879F97B5CBC}" type="slidenum">
               <a:rPr lang="en-US"/>
-              <a:t>3</a:t>
+              <a:t>32</a:t>
             </a:fld>
             <a:endParaRPr lang="en-US"/>
           </a:p>
@@ -2535,7 +2801,7 @@
 </p:notes>
 </file>
 
-<file path=ppt/notesSlides/notesSlide30.xml><?xml version="1.0" encoding="utf-8"?>
+<file path=ppt/notesSlides/notesSlide33.xml><?xml version="1.0" encoding="utf-8"?>
 <p:notes xmlns:a="http://schemas.openxmlformats.org/drawingml/2006/main" xmlns:r="http://schemas.openxmlformats.org/officeDocument/2006/relationships" xmlns:p="http://schemas.openxmlformats.org/presentationml/2006/main">
   <p:cSld>
     <p:spTree>
@@ -2581,7 +2847,7 @@
           <a:p>
             <a:r>
               <a:rPr lang="en-US" dirty="0"/>
-              <a:t>The deepest reason to manage context: accuracy. Not cost. Not speed.</a:t>
+              <a:t/>
             </a:r>
             <a:endParaRPr lang="en-US" dirty="0"/>
           </a:p>
@@ -2604,7 +2870,7 @@
           <a:p>
             <a:fld id="{F7021451-1387-4CA6-816F-3879F97B5CBC}" type="slidenum">
               <a:rPr lang="en-US"/>
-              <a:t>30</a:t>
+              <a:t>33</a:t>
             </a:fld>
             <a:endParaRPr lang="en-US"/>
           </a:p>
@@ -2623,7 +2889,7 @@
 </p:notes>
 </file>
 
-<file path=ppt/notesSlides/notesSlide31.xml><?xml version="1.0" encoding="utf-8"?>
+<file path=ppt/notesSlides/notesSlide34.xml><?xml version="1.0" encoding="utf-8"?>
 <p:notes xmlns:a="http://schemas.openxmlformats.org/drawingml/2006/main" xmlns:r="http://schemas.openxmlformats.org/officeDocument/2006/relationships" xmlns:p="http://schemas.openxmlformats.org/presentationml/2006/main">
   <p:cSld>
     <p:spTree>
@@ -2669,7 +2935,7 @@
           <a:p>
             <a:r>
               <a:rPr lang="en-US" dirty="0"/>
-              <a:t/>
+              <a:t>Two axes. Confusing them = bad model choices.</a:t>
             </a:r>
             <a:endParaRPr lang="en-US" dirty="0"/>
           </a:p>
@@ -2692,7 +2958,7 @@
           <a:p>
             <a:fld id="{F7021451-1387-4CA6-816F-3879F97B5CBC}" type="slidenum">
               <a:rPr lang="en-US"/>
-              <a:t>31</a:t>
+              <a:t>34</a:t>
             </a:fld>
             <a:endParaRPr lang="en-US"/>
           </a:p>
@@ -2711,183 +2977,7 @@
 </p:notes>
 </file>
 
-<file path=ppt/notesSlides/notesSlide32.xml><?xml version="1.0" encoding="utf-8"?>
-<p:notes xmlns:a="http://schemas.openxmlformats.org/drawingml/2006/main" xmlns:r="http://schemas.openxmlformats.org/officeDocument/2006/relationships" xmlns:p="http://schemas.openxmlformats.org/presentationml/2006/main">
-  <p:cSld>
-    <p:spTree>
-      <p:nvGrpSpPr>
-        <p:cNvPr id="1" name=""/>
-        <p:cNvGrpSpPr/>
-        <p:nvPr/>
-      </p:nvGrpSpPr>
-      <p:grpSpPr>
-        <a:xfrm>
-          <a:off x="0" y="0"/>
-          <a:ext cx="0" cy="0"/>
-          <a:chOff x="0" y="0"/>
-          <a:chExt cx="0" cy="0"/>
-        </a:xfrm>
-      </p:grpSpPr>
-      <p:sp>
-        <p:nvSpPr>
-          <p:cNvPr id="2" name="Slide Image Placeholder 1"/>
-          <p:cNvSpPr>
-            <a:spLocks noGrp="1" noRot="1" noChangeAspect="1"/>
-          </p:cNvSpPr>
-          <p:nvPr>
-            <p:ph type="sldImg"/>
-          </p:nvPr>
-        </p:nvSpPr>
-        <p:spPr/>
-      </p:sp>
-      <p:sp>
-        <p:nvSpPr>
-          <p:cNvPr id="3" name="Notes Placeholder 2"/>
-          <p:cNvSpPr>
-            <a:spLocks noGrp="1"/>
-          </p:cNvSpPr>
-          <p:nvPr>
-            <p:ph type="body" idx="1"/>
-          </p:nvPr>
-        </p:nvSpPr>
-        <p:spPr/>
-        <p:txBody>
-          <a:bodyPr/>
-          <a:lstStyle/>
-          <a:p>
-            <a:r>
-              <a:rPr lang="en-US" dirty="0"/>
-              <a:t/>
-            </a:r>
-            <a:endParaRPr lang="en-US" dirty="0"/>
-          </a:p>
-        </p:txBody>
-      </p:sp>
-      <p:sp>
-        <p:nvSpPr>
-          <p:cNvPr id="4" name="Slide Number Placeholder 3"/>
-          <p:cNvSpPr>
-            <a:spLocks noGrp="1"/>
-          </p:cNvSpPr>
-          <p:nvPr>
-            <p:ph type="sldNum" sz="quarter" idx="10"/>
-          </p:nvPr>
-        </p:nvSpPr>
-        <p:spPr/>
-        <p:txBody>
-          <a:bodyPr/>
-          <a:lstStyle/>
-          <a:p>
-            <a:fld id="{F7021451-1387-4CA6-816F-3879F97B5CBC}" type="slidenum">
-              <a:rPr lang="en-US"/>
-              <a:t>32</a:t>
-            </a:fld>
-            <a:endParaRPr lang="en-US"/>
-          </a:p>
-        </p:txBody>
-      </p:sp>
-    </p:spTree>
-    <p:extLst>
-      <p:ext uri="{BB962C8B-B14F-4D97-AF65-F5344CB8AC3E}">
-        <p14:creationId xmlns:p14="http://schemas.microsoft.com/office/powerpoint/2010/main" val="1024086991"/>
-      </p:ext>
-    </p:extLst>
-  </p:cSld>
-  <p:clrMapOvr>
-    <a:masterClrMapping/>
-  </p:clrMapOvr>
-</p:notes>
-</file>
-
-<file path=ppt/notesSlides/notesSlide33.xml><?xml version="1.0" encoding="utf-8"?>
-<p:notes xmlns:a="http://schemas.openxmlformats.org/drawingml/2006/main" xmlns:r="http://schemas.openxmlformats.org/officeDocument/2006/relationships" xmlns:p="http://schemas.openxmlformats.org/presentationml/2006/main">
-  <p:cSld>
-    <p:spTree>
-      <p:nvGrpSpPr>
-        <p:cNvPr id="1" name=""/>
-        <p:cNvGrpSpPr/>
-        <p:nvPr/>
-      </p:nvGrpSpPr>
-      <p:grpSpPr>
-        <a:xfrm>
-          <a:off x="0" y="0"/>
-          <a:ext cx="0" cy="0"/>
-          <a:chOff x="0" y="0"/>
-          <a:chExt cx="0" cy="0"/>
-        </a:xfrm>
-      </p:grpSpPr>
-      <p:sp>
-        <p:nvSpPr>
-          <p:cNvPr id="2" name="Slide Image Placeholder 1"/>
-          <p:cNvSpPr>
-            <a:spLocks noGrp="1" noRot="1" noChangeAspect="1"/>
-          </p:cNvSpPr>
-          <p:nvPr>
-            <p:ph type="sldImg"/>
-          </p:nvPr>
-        </p:nvSpPr>
-        <p:spPr/>
-      </p:sp>
-      <p:sp>
-        <p:nvSpPr>
-          <p:cNvPr id="3" name="Notes Placeholder 2"/>
-          <p:cNvSpPr>
-            <a:spLocks noGrp="1"/>
-          </p:cNvSpPr>
-          <p:nvPr>
-            <p:ph type="body" idx="1"/>
-          </p:nvPr>
-        </p:nvSpPr>
-        <p:spPr/>
-        <p:txBody>
-          <a:bodyPr/>
-          <a:lstStyle/>
-          <a:p>
-            <a:r>
-              <a:rPr lang="en-US" dirty="0"/>
-              <a:t>Two axes. Confusing them = bad model choices.</a:t>
-            </a:r>
-            <a:endParaRPr lang="en-US" dirty="0"/>
-          </a:p>
-        </p:txBody>
-      </p:sp>
-      <p:sp>
-        <p:nvSpPr>
-          <p:cNvPr id="4" name="Slide Number Placeholder 3"/>
-          <p:cNvSpPr>
-            <a:spLocks noGrp="1"/>
-          </p:cNvSpPr>
-          <p:nvPr>
-            <p:ph type="sldNum" sz="quarter" idx="10"/>
-          </p:nvPr>
-        </p:nvSpPr>
-        <p:spPr/>
-        <p:txBody>
-          <a:bodyPr/>
-          <a:lstStyle/>
-          <a:p>
-            <a:fld id="{F7021451-1387-4CA6-816F-3879F97B5CBC}" type="slidenum">
-              <a:rPr lang="en-US"/>
-              <a:t>33</a:t>
-            </a:fld>
-            <a:endParaRPr lang="en-US"/>
-          </a:p>
-        </p:txBody>
-      </p:sp>
-    </p:spTree>
-    <p:extLst>
-      <p:ext uri="{BB962C8B-B14F-4D97-AF65-F5344CB8AC3E}">
-        <p14:creationId xmlns:p14="http://schemas.microsoft.com/office/powerpoint/2010/main" val="1024086991"/>
-      </p:ext>
-    </p:extLst>
-  </p:cSld>
-  <p:clrMapOvr>
-    <a:masterClrMapping/>
-  </p:clrMapOvr>
-</p:notes>
-</file>
-
-<file path=ppt/notesSlides/notesSlide34.xml><?xml version="1.0" encoding="utf-8"?>
+<file path=ppt/notesSlides/notesSlide35.xml><?xml version="1.0" encoding="utf-8"?>
 <p:notes xmlns:a="http://schemas.openxmlformats.org/drawingml/2006/main" xmlns:r="http://schemas.openxmlformats.org/officeDocument/2006/relationships" xmlns:p="http://schemas.openxmlformats.org/presentationml/2006/main">
   <p:cSld>
     <p:spTree>
@@ -2959,7 +3049,7 @@
           <a:p>
             <a:fld id="{F7021451-1387-4CA6-816F-3879F97B5CBC}" type="slidenum">
               <a:rPr lang="en-US"/>
-              <a:t>34</a:t>
+              <a:t>35</a:t>
             </a:fld>
             <a:endParaRPr lang="en-US"/>
           </a:p>
@@ -2978,7 +3068,7 @@
 </p:notes>
 </file>
 
-<file path=ppt/notesSlides/notesSlide35.xml><?xml version="1.0" encoding="utf-8"?>
+<file path=ppt/notesSlides/notesSlide36.xml><?xml version="1.0" encoding="utf-8"?>
 <p:notes xmlns:a="http://schemas.openxmlformats.org/drawingml/2006/main" xmlns:r="http://schemas.openxmlformats.org/officeDocument/2006/relationships" xmlns:p="http://schemas.openxmlformats.org/presentationml/2006/main">
   <p:cSld>
     <p:spTree>
@@ -3047,7 +3137,7 @@
           <a:p>
             <a:fld id="{F7021451-1387-4CA6-816F-3879F97B5CBC}" type="slidenum">
               <a:rPr lang="en-US"/>
-              <a:t>35</a:t>
+              <a:t>36</a:t>
             </a:fld>
             <a:endParaRPr lang="en-US"/>
           </a:p>
@@ -3066,7 +3156,7 @@
 </p:notes>
 </file>
 
-<file path=ppt/notesSlides/notesSlide36.xml><?xml version="1.0" encoding="utf-8"?>
+<file path=ppt/notesSlides/notesSlide37.xml><?xml version="1.0" encoding="utf-8"?>
 <p:notes xmlns:a="http://schemas.openxmlformats.org/drawingml/2006/main" xmlns:r="http://schemas.openxmlformats.org/officeDocument/2006/relationships" xmlns:p="http://schemas.openxmlformats.org/presentationml/2006/main">
   <p:cSld>
     <p:spTree>
@@ -3135,7 +3225,7 @@
           <a:p>
             <a:fld id="{F7021451-1387-4CA6-816F-3879F97B5CBC}" type="slidenum">
               <a:rPr lang="en-US"/>
-              <a:t>36</a:t>
+              <a:t>37</a:t>
             </a:fld>
             <a:endParaRPr lang="en-US"/>
           </a:p>
@@ -3154,7 +3244,7 @@
 </p:notes>
 </file>
 
-<file path=ppt/notesSlides/notesSlide37.xml><?xml version="1.0" encoding="utf-8"?>
+<file path=ppt/notesSlides/notesSlide38.xml><?xml version="1.0" encoding="utf-8"?>
 <p:notes xmlns:a="http://schemas.openxmlformats.org/drawingml/2006/main" xmlns:r="http://schemas.openxmlformats.org/officeDocument/2006/relationships" xmlns:p="http://schemas.openxmlformats.org/presentationml/2006/main">
   <p:cSld>
     <p:spTree>
@@ -3223,7 +3313,7 @@
           <a:p>
             <a:fld id="{F7021451-1387-4CA6-816F-3879F97B5CBC}" type="slidenum">
               <a:rPr lang="en-US"/>
-              <a:t>37</a:t>
+              <a:t>38</a:t>
             </a:fld>
             <a:endParaRPr lang="en-US"/>
           </a:p>
@@ -3242,7 +3332,7 @@
 </p:notes>
 </file>
 
-<file path=ppt/notesSlides/notesSlide38.xml><?xml version="1.0" encoding="utf-8"?>
+<file path=ppt/notesSlides/notesSlide39.xml><?xml version="1.0" encoding="utf-8"?>
 <p:notes xmlns:a="http://schemas.openxmlformats.org/drawingml/2006/main" xmlns:r="http://schemas.openxmlformats.org/officeDocument/2006/relationships" xmlns:p="http://schemas.openxmlformats.org/presentationml/2006/main">
   <p:cSld>
     <p:spTree>
@@ -3311,7 +3401,7 @@
           <a:p>
             <a:fld id="{F7021451-1387-4CA6-816F-3879F97B5CBC}" type="slidenum">
               <a:rPr lang="en-US"/>
-              <a:t>38</a:t>
+              <a:t>39</a:t>
             </a:fld>
             <a:endParaRPr lang="en-US"/>
           </a:p>
@@ -3330,7 +3420,7 @@
 </p:notes>
 </file>
 
-<file path=ppt/notesSlides/notesSlide39.xml><?xml version="1.0" encoding="utf-8"?>
+<file path=ppt/notesSlides/notesSlide4.xml><?xml version="1.0" encoding="utf-8"?>
 <p:notes xmlns:a="http://schemas.openxmlformats.org/drawingml/2006/main" xmlns:r="http://schemas.openxmlformats.org/officeDocument/2006/relationships" xmlns:p="http://schemas.openxmlformats.org/presentationml/2006/main">
   <p:cSld>
     <p:spTree>
@@ -3399,7 +3489,7 @@
           <a:p>
             <a:fld id="{F7021451-1387-4CA6-816F-3879F97B5CBC}" type="slidenum">
               <a:rPr lang="en-US"/>
-              <a:t>39</a:t>
+              <a:t>4</a:t>
             </a:fld>
             <a:endParaRPr lang="en-US"/>
           </a:p>
@@ -3418,7 +3508,7 @@
 </p:notes>
 </file>
 
-<file path=ppt/notesSlides/notesSlide4.xml><?xml version="1.0" encoding="utf-8"?>
+<file path=ppt/notesSlides/notesSlide40.xml><?xml version="1.0" encoding="utf-8"?>
 <p:notes xmlns:a="http://schemas.openxmlformats.org/drawingml/2006/main" xmlns:r="http://schemas.openxmlformats.org/officeDocument/2006/relationships" xmlns:p="http://schemas.openxmlformats.org/presentationml/2006/main">
   <p:cSld>
     <p:spTree>
@@ -3487,7 +3577,7 @@
           <a:p>
             <a:fld id="{F7021451-1387-4CA6-816F-3879F97B5CBC}" type="slidenum">
               <a:rPr lang="en-US"/>
-              <a:t>4</a:t>
+              <a:t>40</a:t>
             </a:fld>
             <a:endParaRPr lang="en-US"/>
           </a:p>
@@ -3506,7 +3596,7 @@
 </p:notes>
 </file>
 
-<file path=ppt/notesSlides/notesSlide40.xml><?xml version="1.0" encoding="utf-8"?>
+<file path=ppt/notesSlides/notesSlide41.xml><?xml version="1.0" encoding="utf-8"?>
 <p:notes xmlns:a="http://schemas.openxmlformats.org/drawingml/2006/main" xmlns:r="http://schemas.openxmlformats.org/officeDocument/2006/relationships" xmlns:p="http://schemas.openxmlformats.org/presentationml/2006/main">
   <p:cSld>
     <p:spTree>
@@ -3575,7 +3665,7 @@
           <a:p>
             <a:fld id="{F7021451-1387-4CA6-816F-3879F97B5CBC}" type="slidenum">
               <a:rPr lang="en-US"/>
-              <a:t>40</a:t>
+              <a:t>41</a:t>
             </a:fld>
             <a:endParaRPr lang="en-US"/>
           </a:p>
@@ -3594,7 +3684,7 @@
 </p:notes>
 </file>
 
-<file path=ppt/notesSlides/notesSlide41.xml><?xml version="1.0" encoding="utf-8"?>
+<file path=ppt/notesSlides/notesSlide42.xml><?xml version="1.0" encoding="utf-8"?>
 <p:notes xmlns:a="http://schemas.openxmlformats.org/drawingml/2006/main" xmlns:r="http://schemas.openxmlformats.org/officeDocument/2006/relationships" xmlns:p="http://schemas.openxmlformats.org/presentationml/2006/main">
   <p:cSld>
     <p:spTree>
@@ -3663,7 +3753,7 @@
           <a:p>
             <a:fld id="{F7021451-1387-4CA6-816F-3879F97B5CBC}" type="slidenum">
               <a:rPr lang="en-US"/>
-              <a:t>41</a:t>
+              <a:t>42</a:t>
             </a:fld>
             <a:endParaRPr lang="en-US"/>
           </a:p>
@@ -3682,7 +3772,7 @@
 </p:notes>
 </file>
 
-<file path=ppt/notesSlides/notesSlide42.xml><?xml version="1.0" encoding="utf-8"?>
+<file path=ppt/notesSlides/notesSlide43.xml><?xml version="1.0" encoding="utf-8"?>
 <p:notes xmlns:a="http://schemas.openxmlformats.org/drawingml/2006/main" xmlns:r="http://schemas.openxmlformats.org/officeDocument/2006/relationships" xmlns:p="http://schemas.openxmlformats.org/presentationml/2006/main">
   <p:cSld>
     <p:spTree>
@@ -3752,7 +3842,7 @@
           <a:p>
             <a:fld id="{F7021451-1387-4CA6-816F-3879F97B5CBC}" type="slidenum">
               <a:rPr lang="en-US"/>
-              <a:t>42</a:t>
+              <a:t>43</a:t>
             </a:fld>
             <a:endParaRPr lang="en-US"/>
           </a:p>
@@ -3771,7 +3861,7 @@
 </p:notes>
 </file>
 
-<file path=ppt/notesSlides/notesSlide43.xml><?xml version="1.0" encoding="utf-8"?>
+<file path=ppt/notesSlides/notesSlide44.xml><?xml version="1.0" encoding="utf-8"?>
 <p:notes xmlns:a="http://schemas.openxmlformats.org/drawingml/2006/main" xmlns:r="http://schemas.openxmlformats.org/officeDocument/2006/relationships" xmlns:p="http://schemas.openxmlformats.org/presentationml/2006/main">
   <p:cSld>
     <p:spTree>
@@ -3840,7 +3930,7 @@
           <a:p>
             <a:fld id="{F7021451-1387-4CA6-816F-3879F97B5CBC}" type="slidenum">
               <a:rPr lang="en-US"/>
-              <a:t>43</a:t>
+              <a:t>44</a:t>
             </a:fld>
             <a:endParaRPr lang="en-US"/>
           </a:p>
@@ -3859,7 +3949,7 @@
 </p:notes>
 </file>
 
-<file path=ppt/notesSlides/notesSlide44.xml><?xml version="1.0" encoding="utf-8"?>
+<file path=ppt/notesSlides/notesSlide45.xml><?xml version="1.0" encoding="utf-8"?>
 <p:notes xmlns:a="http://schemas.openxmlformats.org/drawingml/2006/main" xmlns:r="http://schemas.openxmlformats.org/officeDocument/2006/relationships" xmlns:p="http://schemas.openxmlformats.org/presentationml/2006/main">
   <p:cSld>
     <p:spTree>
@@ -3928,7 +4018,7 @@
           <a:p>
             <a:fld id="{F7021451-1387-4CA6-816F-3879F97B5CBC}" type="slidenum">
               <a:rPr lang="en-US"/>
-              <a:t>44</a:t>
+              <a:t>45</a:t>
             </a:fld>
             <a:endParaRPr lang="en-US"/>
           </a:p>
@@ -3947,7 +4037,7 @@
 </p:notes>
 </file>
 
-<file path=ppt/notesSlides/notesSlide45.xml><?xml version="1.0" encoding="utf-8"?>
+<file path=ppt/notesSlides/notesSlide46.xml><?xml version="1.0" encoding="utf-8"?>
 <p:notes xmlns:a="http://schemas.openxmlformats.org/drawingml/2006/main" xmlns:r="http://schemas.openxmlformats.org/officeDocument/2006/relationships" xmlns:p="http://schemas.openxmlformats.org/presentationml/2006/main">
   <p:cSld>
     <p:spTree>
@@ -4016,7 +4106,7 @@
           <a:p>
             <a:fld id="{F7021451-1387-4CA6-816F-3879F97B5CBC}" type="slidenum">
               <a:rPr lang="en-US"/>
-              <a:t>45</a:t>
+              <a:t>46</a:t>
             </a:fld>
             <a:endParaRPr lang="en-US"/>
           </a:p>
@@ -4035,6 +4125,96 @@
 </p:notes>
 </file>
 
+<file path=ppt/notesSlides/notesSlide47.xml><?xml version="1.0" encoding="utf-8"?>
+<p:notes xmlns:a="http://schemas.openxmlformats.org/drawingml/2006/main" xmlns:r="http://schemas.openxmlformats.org/officeDocument/2006/relationships" xmlns:p="http://schemas.openxmlformats.org/presentationml/2006/main">
+  <p:cSld>
+    <p:spTree>
+      <p:nvGrpSpPr>
+        <p:cNvPr id="1" name=""/>
+        <p:cNvGrpSpPr/>
+        <p:nvPr/>
+      </p:nvGrpSpPr>
+      <p:grpSpPr>
+        <a:xfrm>
+          <a:off x="0" y="0"/>
+          <a:ext cx="0" cy="0"/>
+          <a:chOff x="0" y="0"/>
+          <a:chExt cx="0" cy="0"/>
+        </a:xfrm>
+      </p:grpSpPr>
+      <p:sp>
+        <p:nvSpPr>
+          <p:cNvPr id="2" name="Slide Image Placeholder 1"/>
+          <p:cNvSpPr>
+            <a:spLocks noGrp="1" noRot="1" noChangeAspect="1"/>
+          </p:cNvSpPr>
+          <p:nvPr>
+            <p:ph type="sldImg"/>
+          </p:nvPr>
+        </p:nvSpPr>
+        <p:spPr/>
+      </p:sp>
+      <p:sp>
+        <p:nvSpPr>
+          <p:cNvPr id="3" name="Notes Placeholder 2"/>
+          <p:cNvSpPr>
+            <a:spLocks noGrp="1"/>
+          </p:cNvSpPr>
+          <p:nvPr>
+            <p:ph type="body" idx="1"/>
+          </p:nvPr>
+        </p:nvSpPr>
+        <p:spPr/>
+        <p:txBody>
+          <a:bodyPr/>
+          <a:lstStyle/>
+          <a:p>
+            <a:r>
+              <a:rPr lang="en-US" dirty="0"/>
+              <a:t>Leave this up while the room files out. Not assessed, not required.
+The tokenizer video is long; tell them the first 30 minutes is the part
+that pays for itself.</a:t>
+            </a:r>
+            <a:endParaRPr lang="en-US" dirty="0"/>
+          </a:p>
+        </p:txBody>
+      </p:sp>
+      <p:sp>
+        <p:nvSpPr>
+          <p:cNvPr id="4" name="Slide Number Placeholder 3"/>
+          <p:cNvSpPr>
+            <a:spLocks noGrp="1"/>
+          </p:cNvSpPr>
+          <p:nvPr>
+            <p:ph type="sldNum" sz="quarter" idx="10"/>
+          </p:nvPr>
+        </p:nvSpPr>
+        <p:spPr/>
+        <p:txBody>
+          <a:bodyPr/>
+          <a:lstStyle/>
+          <a:p>
+            <a:fld id="{F7021451-1387-4CA6-816F-3879F97B5CBC}" type="slidenum">
+              <a:rPr lang="en-US"/>
+              <a:t>47</a:t>
+            </a:fld>
+            <a:endParaRPr lang="en-US"/>
+          </a:p>
+        </p:txBody>
+      </p:sp>
+    </p:spTree>
+    <p:extLst>
+      <p:ext uri="{BB962C8B-B14F-4D97-AF65-F5344CB8AC3E}">
+        <p14:creationId xmlns:p14="http://schemas.microsoft.com/office/powerpoint/2010/main" val="1024086991"/>
+      </p:ext>
+    </p:extLst>
+  </p:cSld>
+  <p:clrMapOvr>
+    <a:masterClrMapping/>
+  </p:clrMapOvr>
+</p:notes>
+</file>
+
 <file path=ppt/notesSlides/notesSlide5.xml><?xml version="1.0" encoding="utf-8"?>
 <p:notes xmlns:a="http://schemas.openxmlformats.org/drawingml/2006/main" xmlns:r="http://schemas.openxmlformats.org/officeDocument/2006/relationships" xmlns:p="http://schemas.openxmlformats.org/presentationml/2006/main">
   <p:cSld>
@@ -4257,7 +4437,14 @@
           <a:p>
             <a:r>
               <a:rPr lang="en-US" dirty="0"/>
-              <a:t/>
+              <a:t>This is the payoff for the previous slide: getOrderById really does come
+back as get / Order / By / Id, and here are the numbers.
+Two things to point at if there is time. The dot in the middle of a chip
+is a leading space, which is part of the token, so " order" and "order"
+are different tokens. And "(order" is one token: the tokenizer swallowed
+the paren with the word, which is why token counts are hard to guess.
+Caveat if asked: these IDs are o200k_base. qwen3.5 uses a different
+vocabulary, so the numbers differ. The idea does not.</a:t>
             </a:r>
             <a:endParaRPr lang="en-US" dirty="0"/>
           </a:p>
@@ -4345,8 +4532,7 @@
           <a:p>
             <a:r>
               <a:rPr lang="en-US" dirty="0"/>
-              <a:t>Same function. Verbose costs 4× more.
-Not "more informative" — more expensive and more distracting.</a:t>
+              <a:t/>
             </a:r>
             <a:endParaRPr lang="en-US" dirty="0"/>
           </a:p>
@@ -4434,7 +4620,8 @@
           <a:p>
             <a:r>
               <a:rPr lang="en-US" dirty="0"/>
-              <a:t/>
+              <a:t>Same function. Verbose costs 4× more.
+Not "more informative" — more expensive and more distracting.</a:t>
             </a:r>
             <a:endParaRPr lang="en-US" dirty="0"/>
           </a:p>
@@ -6307,6 +6494,84 @@
 <file path=ppt/slides/slide45.xml><?xml version="1.0" encoding="utf-8"?>
 <p:sld xmlns:a="http://schemas.openxmlformats.org/drawingml/2006/main" xmlns:r="http://schemas.openxmlformats.org/officeDocument/2006/relationships" xmlns:p="http://schemas.openxmlformats.org/presentationml/2006/main">
   <p:cSld name="Slide 45">
+    <p:bg>
+      <p:bgPr>
+        <a:blipFill dpi="0" rotWithShape="1">
+          <a:blip r:embed="rId1">
+            <a:lum/>
+          </a:blip>
+          <a:srcRect/>
+          <a:stretch>
+            <a:fillRect/>
+          </a:stretch>
+        </a:blipFill>
+        <a:effectLst/>
+      </p:bgPr>
+    </p:bg>
+    <p:spTree>
+      <p:nvGrpSpPr>
+        <p:cNvPr id="1" name=""/>
+        <p:cNvGrpSpPr/>
+        <p:nvPr/>
+      </p:nvGrpSpPr>
+      <p:grpSpPr>
+        <a:xfrm>
+          <a:off x="0" y="0"/>
+          <a:ext cx="0" cy="0"/>
+          <a:chOff x="0" y="0"/>
+          <a:chExt cx="0" cy="0"/>
+        </a:xfrm>
+      </p:grpSpPr>
+    </p:spTree>
+  </p:cSld>
+  <p:clrMapOvr>
+    <a:masterClrMapping/>
+  </p:clrMapOvr>
+</p:sld>
+</file>
+
+<file path=ppt/slides/slide46.xml><?xml version="1.0" encoding="utf-8"?>
+<p:sld xmlns:a="http://schemas.openxmlformats.org/drawingml/2006/main" xmlns:r="http://schemas.openxmlformats.org/officeDocument/2006/relationships" xmlns:p="http://schemas.openxmlformats.org/presentationml/2006/main">
+  <p:cSld name="Slide 46">
+    <p:bg>
+      <p:bgPr>
+        <a:blipFill dpi="0" rotWithShape="1">
+          <a:blip r:embed="rId1">
+            <a:lum/>
+          </a:blip>
+          <a:srcRect/>
+          <a:stretch>
+            <a:fillRect/>
+          </a:stretch>
+        </a:blipFill>
+        <a:effectLst/>
+      </p:bgPr>
+    </p:bg>
+    <p:spTree>
+      <p:nvGrpSpPr>
+        <p:cNvPr id="1" name=""/>
+        <p:cNvGrpSpPr/>
+        <p:nvPr/>
+      </p:nvGrpSpPr>
+      <p:grpSpPr>
+        <a:xfrm>
+          <a:off x="0" y="0"/>
+          <a:ext cx="0" cy="0"/>
+          <a:chOff x="0" y="0"/>
+          <a:chExt cx="0" cy="0"/>
+        </a:xfrm>
+      </p:grpSpPr>
+    </p:spTree>
+  </p:cSld>
+  <p:clrMapOvr>
+    <a:masterClrMapping/>
+  </p:clrMapOvr>
+</p:sld>
+</file>
+
+<file path=ppt/slides/slide47.xml><?xml version="1.0" encoding="utf-8"?>
+<p:sld xmlns:a="http://schemas.openxmlformats.org/drawingml/2006/main" xmlns:r="http://schemas.openxmlformats.org/officeDocument/2006/relationships" xmlns:p="http://schemas.openxmlformats.org/presentationml/2006/main">
+  <p:cSld name="Slide 47">
     <p:bg>
       <p:bgPr>
         <a:blipFill dpi="0" rotWithShape="1">

</xml_diff>